<commit_message>
Refine Diffusion and Tokenization slides and update video tutorials
- Correct and clarify the Diffusion and Tokenization presentations in PDF and PowerPoint formats.
- Update the corresponding video tutorials and English SRT subtitles to reflect the revised slides.
- Remove the three VTT caption files, with browser caption regeneration and GitHub Pages updates deferred to a follow-up.
</commit_message>
<xml_diff>
--- a/UnderstandingTokenization/UnderstandingTokenization.pptx
+++ b/UnderstandingTokenization/UnderstandingTokenization.pptx
@@ -298,7 +298,7 @@
 <file path=ppt/revisionInfo.xml><?xml version="1.0" encoding="utf-8"?>
 <p1510:revInfo xmlns:a="http://schemas.openxmlformats.org/drawingml/2006/main" xmlns:r="http://schemas.openxmlformats.org/officeDocument/2006/relationships" xmlns:p1510="http://schemas.microsoft.com/office/powerpoint/2015/10/main">
   <p1510:revLst>
-    <p1510:client id="{773B4E21-E7BC-4BEB-A450-0E7E351A2DCC}" v="5" dt="2026-10-02T08:49:55.480"/>
+    <p1510:client id="{A587FBBB-A36E-4A23-A98B-27184C691C8F}" v="15" dt="2026-10-06T10:45:07.553"/>
   </p1510:revLst>
 </p1510:revInfo>
 </file>
@@ -308,10 +308,95 @@
   <pc:docChgLst>
     <pc:chgData name="Caus, Danu" userId="76bbb7e8-a05c-4774-86b8-3bcd1c5d58b7" providerId="ADAL" clId="{25141FD5-A6FE-43F2-8E7E-7262B0A5DBE9}"/>
     <pc:docChg chg="undo custSel modSld">
-      <pc:chgData name="Caus, Danu" userId="76bbb7e8-a05c-4774-86b8-3bcd1c5d58b7" providerId="ADAL" clId="{25141FD5-A6FE-43F2-8E7E-7262B0A5DBE9}" dt="2026-10-02T10:39:46.325" v="119" actId="1076"/>
+      <pc:chgData name="Caus, Danu" userId="76bbb7e8-a05c-4774-86b8-3bcd1c5d58b7" providerId="ADAL" clId="{25141FD5-A6FE-43F2-8E7E-7262B0A5DBE9}" dt="2026-10-06T11:48:07.034" v="705" actId="1035"/>
       <pc:docMkLst>
         <pc:docMk/>
       </pc:docMkLst>
+      <pc:sldChg chg="modSp mod">
+        <pc:chgData name="Caus, Danu" userId="76bbb7e8-a05c-4774-86b8-3bcd1c5d58b7" providerId="ADAL" clId="{25141FD5-A6FE-43F2-8E7E-7262B0A5DBE9}" dt="2026-10-06T11:48:07.034" v="705" actId="1035"/>
+        <pc:sldMkLst>
+          <pc:docMk/>
+          <pc:sldMk cId="0" sldId="256"/>
+        </pc:sldMkLst>
+        <pc:spChg chg="mod">
+          <ac:chgData name="Caus, Danu" userId="76bbb7e8-a05c-4774-86b8-3bcd1c5d58b7" providerId="ADAL" clId="{25141FD5-A6FE-43F2-8E7E-7262B0A5DBE9}" dt="2026-10-06T11:48:07.034" v="705" actId="1035"/>
+          <ac:spMkLst>
+            <pc:docMk/>
+            <pc:sldMk cId="0" sldId="256"/>
+            <ac:spMk id="54" creationId="{00000000-0000-0000-0000-000000000000}"/>
+          </ac:spMkLst>
+        </pc:spChg>
+      </pc:sldChg>
+      <pc:sldChg chg="modSp mod">
+        <pc:chgData name="Caus, Danu" userId="76bbb7e8-a05c-4774-86b8-3bcd1c5d58b7" providerId="ADAL" clId="{25141FD5-A6FE-43F2-8E7E-7262B0A5DBE9}" dt="2026-10-06T10:36:25.706" v="666" actId="1076"/>
+        <pc:sldMkLst>
+          <pc:docMk/>
+          <pc:sldMk cId="0" sldId="260"/>
+        </pc:sldMkLst>
+        <pc:spChg chg="mod">
+          <ac:chgData name="Caus, Danu" userId="76bbb7e8-a05c-4774-86b8-3bcd1c5d58b7" providerId="ADAL" clId="{25141FD5-A6FE-43F2-8E7E-7262B0A5DBE9}" dt="2026-10-06T10:36:25.706" v="666" actId="1076"/>
+          <ac:spMkLst>
+            <pc:docMk/>
+            <pc:sldMk cId="0" sldId="260"/>
+            <ac:spMk id="91" creationId="{00000000-0000-0000-0000-000000000000}"/>
+          </ac:spMkLst>
+        </pc:spChg>
+        <pc:spChg chg="mod">
+          <ac:chgData name="Caus, Danu" userId="76bbb7e8-a05c-4774-86b8-3bcd1c5d58b7" providerId="ADAL" clId="{25141FD5-A6FE-43F2-8E7E-7262B0A5DBE9}" dt="2026-10-06T07:02:25.555" v="215" actId="1076"/>
+          <ac:spMkLst>
+            <pc:docMk/>
+            <pc:sldMk cId="0" sldId="260"/>
+            <ac:spMk id="94" creationId="{00000000-0000-0000-0000-000000000000}"/>
+          </ac:spMkLst>
+        </pc:spChg>
+        <pc:spChg chg="mod">
+          <ac:chgData name="Caus, Danu" userId="76bbb7e8-a05c-4774-86b8-3bcd1c5d58b7" providerId="ADAL" clId="{25141FD5-A6FE-43F2-8E7E-7262B0A5DBE9}" dt="2026-10-06T07:09:02.473" v="250" actId="1076"/>
+          <ac:spMkLst>
+            <pc:docMk/>
+            <pc:sldMk cId="0" sldId="260"/>
+            <ac:spMk id="95" creationId="{00000000-0000-0000-0000-000000000000}"/>
+          </ac:spMkLst>
+        </pc:spChg>
+        <pc:spChg chg="mod">
+          <ac:chgData name="Caus, Danu" userId="76bbb7e8-a05c-4774-86b8-3bcd1c5d58b7" providerId="ADAL" clId="{25141FD5-A6FE-43F2-8E7E-7262B0A5DBE9}" dt="2026-10-06T07:03:29.341" v="238" actId="14100"/>
+          <ac:spMkLst>
+            <pc:docMk/>
+            <pc:sldMk cId="0" sldId="260"/>
+            <ac:spMk id="96" creationId="{00000000-0000-0000-0000-000000000000}"/>
+          </ac:spMkLst>
+        </pc:spChg>
+        <pc:graphicFrameChg chg="mod modGraphic">
+          <ac:chgData name="Caus, Danu" userId="76bbb7e8-a05c-4774-86b8-3bcd1c5d58b7" providerId="ADAL" clId="{25141FD5-A6FE-43F2-8E7E-7262B0A5DBE9}" dt="2026-10-06T07:03:24.513" v="236" actId="14734"/>
+          <ac:graphicFrameMkLst>
+            <pc:docMk/>
+            <pc:sldMk cId="0" sldId="260"/>
+            <ac:graphicFrameMk id="93" creationId="{00000000-0000-0000-0000-000000000000}"/>
+          </ac:graphicFrameMkLst>
+        </pc:graphicFrameChg>
+      </pc:sldChg>
+      <pc:sldChg chg="modSp mod">
+        <pc:chgData name="Caus, Danu" userId="76bbb7e8-a05c-4774-86b8-3bcd1c5d58b7" providerId="ADAL" clId="{25141FD5-A6FE-43F2-8E7E-7262B0A5DBE9}" dt="2026-10-06T10:37:23.022" v="677" actId="20577"/>
+        <pc:sldMkLst>
+          <pc:docMk/>
+          <pc:sldMk cId="0" sldId="265"/>
+        </pc:sldMkLst>
+        <pc:spChg chg="mod">
+          <ac:chgData name="Caus, Danu" userId="76bbb7e8-a05c-4774-86b8-3bcd1c5d58b7" providerId="ADAL" clId="{25141FD5-A6FE-43F2-8E7E-7262B0A5DBE9}" dt="2026-10-06T10:37:23.022" v="677" actId="20577"/>
+          <ac:spMkLst>
+            <pc:docMk/>
+            <pc:sldMk cId="0" sldId="265"/>
+            <ac:spMk id="138" creationId="{00000000-0000-0000-0000-000000000000}"/>
+          </ac:spMkLst>
+        </pc:spChg>
+        <pc:spChg chg="mod">
+          <ac:chgData name="Caus, Danu" userId="76bbb7e8-a05c-4774-86b8-3bcd1c5d58b7" providerId="ADAL" clId="{25141FD5-A6FE-43F2-8E7E-7262B0A5DBE9}" dt="2026-10-06T10:34:10.171" v="665" actId="1076"/>
+          <ac:spMkLst>
+            <pc:docMk/>
+            <pc:sldMk cId="0" sldId="265"/>
+            <ac:spMk id="140" creationId="{00000000-0000-0000-0000-000000000000}"/>
+          </ac:spMkLst>
+        </pc:spChg>
+      </pc:sldChg>
       <pc:sldChg chg="addSp delSp modSp mod">
         <pc:chgData name="Caus, Danu" userId="76bbb7e8-a05c-4774-86b8-3bcd1c5d58b7" providerId="ADAL" clId="{25141FD5-A6FE-43F2-8E7E-7262B0A5DBE9}" dt="2026-10-02T10:21:33.915" v="118" actId="1036"/>
         <pc:sldMkLst>
@@ -334,14 +419,6 @@
             <ac:spMk id="151" creationId="{00000000-0000-0000-0000-000000000000}"/>
           </ac:spMkLst>
         </pc:spChg>
-        <pc:picChg chg="add del mod">
-          <ac:chgData name="Caus, Danu" userId="76bbb7e8-a05c-4774-86b8-3bcd1c5d58b7" providerId="ADAL" clId="{25141FD5-A6FE-43F2-8E7E-7262B0A5DBE9}" dt="2026-10-02T10:20:13.204" v="89" actId="478"/>
-          <ac:picMkLst>
-            <pc:docMk/>
-            <pc:sldMk cId="0" sldId="266"/>
-            <ac:picMk id="3" creationId="{15FE4C4C-BFD2-C976-4D67-8741E370B33D}"/>
-          </ac:picMkLst>
-        </pc:picChg>
         <pc:picChg chg="add mod">
           <ac:chgData name="Caus, Danu" userId="76bbb7e8-a05c-4774-86b8-3bcd1c5d58b7" providerId="ADAL" clId="{25141FD5-A6FE-43F2-8E7E-7262B0A5DBE9}" dt="2026-10-02T10:21:33.915" v="118" actId="1036"/>
           <ac:picMkLst>
@@ -350,23 +427,15 @@
             <ac:picMk id="5" creationId="{2FC9871A-C5D8-1FC3-4C95-8AB16689CAC1}"/>
           </ac:picMkLst>
         </pc:picChg>
-        <pc:picChg chg="del">
-          <ac:chgData name="Caus, Danu" userId="76bbb7e8-a05c-4774-86b8-3bcd1c5d58b7" providerId="ADAL" clId="{25141FD5-A6FE-43F2-8E7E-7262B0A5DBE9}" dt="2026-10-02T10:17:18.221" v="38" actId="478"/>
-          <ac:picMkLst>
-            <pc:docMk/>
-            <pc:sldMk cId="0" sldId="266"/>
-            <ac:picMk id="147" creationId="{00000000-0000-0000-0000-000000000000}"/>
-          </ac:picMkLst>
-        </pc:picChg>
       </pc:sldChg>
       <pc:sldChg chg="addSp modSp mod">
-        <pc:chgData name="Caus, Danu" userId="76bbb7e8-a05c-4774-86b8-3bcd1c5d58b7" providerId="ADAL" clId="{25141FD5-A6FE-43F2-8E7E-7262B0A5DBE9}" dt="2026-10-02T09:45:55.767" v="37" actId="14100"/>
+        <pc:chgData name="Caus, Danu" userId="76bbb7e8-a05c-4774-86b8-3bcd1c5d58b7" providerId="ADAL" clId="{25141FD5-A6FE-43F2-8E7E-7262B0A5DBE9}" dt="2026-10-06T10:48:00.895" v="697" actId="1076"/>
         <pc:sldMkLst>
           <pc:docMk/>
           <pc:sldMk cId="0" sldId="268"/>
         </pc:sldMkLst>
         <pc:spChg chg="mod">
-          <ac:chgData name="Caus, Danu" userId="76bbb7e8-a05c-4774-86b8-3bcd1c5d58b7" providerId="ADAL" clId="{25141FD5-A6FE-43F2-8E7E-7262B0A5DBE9}" dt="2026-10-02T09:45:55.767" v="37" actId="14100"/>
+          <ac:chgData name="Caus, Danu" userId="76bbb7e8-a05c-4774-86b8-3bcd1c5d58b7" providerId="ADAL" clId="{25141FD5-A6FE-43F2-8E7E-7262B0A5DBE9}" dt="2026-10-06T10:47:55.548" v="696" actId="20577"/>
           <ac:spMkLst>
             <pc:docMk/>
             <pc:sldMk cId="0" sldId="268"/>
@@ -382,7 +451,7 @@
           </ac:picMkLst>
         </pc:picChg>
         <pc:picChg chg="add mod">
-          <ac:chgData name="Caus, Danu" userId="76bbb7e8-a05c-4774-86b8-3bcd1c5d58b7" providerId="ADAL" clId="{25141FD5-A6FE-43F2-8E7E-7262B0A5DBE9}" dt="2026-10-02T09:45:19.849" v="36" actId="1076"/>
+          <ac:chgData name="Caus, Danu" userId="76bbb7e8-a05c-4774-86b8-3bcd1c5d58b7" providerId="ADAL" clId="{25141FD5-A6FE-43F2-8E7E-7262B0A5DBE9}" dt="2026-10-06T10:48:00.895" v="697" actId="1076"/>
           <ac:picMkLst>
             <pc:docMk/>
             <pc:sldMk cId="0" sldId="268"/>
@@ -391,11 +460,19 @@
         </pc:picChg>
       </pc:sldChg>
       <pc:sldChg chg="modSp mod">
-        <pc:chgData name="Caus, Danu" userId="76bbb7e8-a05c-4774-86b8-3bcd1c5d58b7" providerId="ADAL" clId="{25141FD5-A6FE-43F2-8E7E-7262B0A5DBE9}" dt="2026-10-02T10:39:46.325" v="119" actId="1076"/>
+        <pc:chgData name="Caus, Danu" userId="76bbb7e8-a05c-4774-86b8-3bcd1c5d58b7" providerId="ADAL" clId="{25141FD5-A6FE-43F2-8E7E-7262B0A5DBE9}" dt="2026-10-06T07:14:17.381" v="258" actId="255"/>
         <pc:sldMkLst>
           <pc:docMk/>
           <pc:sldMk cId="0" sldId="269"/>
         </pc:sldMkLst>
+        <pc:spChg chg="mod">
+          <ac:chgData name="Caus, Danu" userId="76bbb7e8-a05c-4774-86b8-3bcd1c5d58b7" providerId="ADAL" clId="{25141FD5-A6FE-43F2-8E7E-7262B0A5DBE9}" dt="2026-10-06T07:14:17.381" v="258" actId="255"/>
+          <ac:spMkLst>
+            <pc:docMk/>
+            <pc:sldMk cId="0" sldId="269"/>
+            <ac:spMk id="181" creationId="{00000000-0000-0000-0000-000000000000}"/>
+          </ac:spMkLst>
+        </pc:spChg>
         <pc:spChg chg="mod">
           <ac:chgData name="Caus, Danu" userId="76bbb7e8-a05c-4774-86b8-3bcd1c5d58b7" providerId="ADAL" clId="{25141FD5-A6FE-43F2-8E7E-7262B0A5DBE9}" dt="2026-10-02T10:39:46.325" v="119" actId="1076"/>
           <ac:spMkLst>
@@ -404,6 +481,61 @@
             <ac:spMk id="183" creationId="{00000000-0000-0000-0000-000000000000}"/>
           </ac:spMkLst>
         </pc:spChg>
+      </pc:sldChg>
+      <pc:sldChg chg="modSp mod">
+        <pc:chgData name="Caus, Danu" userId="76bbb7e8-a05c-4774-86b8-3bcd1c5d58b7" providerId="ADAL" clId="{25141FD5-A6FE-43F2-8E7E-7262B0A5DBE9}" dt="2026-10-06T10:11:53.244" v="662" actId="113"/>
+        <pc:sldMkLst>
+          <pc:docMk/>
+          <pc:sldMk cId="0" sldId="270"/>
+        </pc:sldMkLst>
+        <pc:spChg chg="mod">
+          <ac:chgData name="Caus, Danu" userId="76bbb7e8-a05c-4774-86b8-3bcd1c5d58b7" providerId="ADAL" clId="{25141FD5-A6FE-43F2-8E7E-7262B0A5DBE9}" dt="2026-10-06T10:02:57.295" v="649"/>
+          <ac:spMkLst>
+            <pc:docMk/>
+            <pc:sldMk cId="0" sldId="270"/>
+            <ac:spMk id="195" creationId="{00000000-0000-0000-0000-000000000000}"/>
+          </ac:spMkLst>
+        </pc:spChg>
+        <pc:spChg chg="mod">
+          <ac:chgData name="Caus, Danu" userId="76bbb7e8-a05c-4774-86b8-3bcd1c5d58b7" providerId="ADAL" clId="{25141FD5-A6FE-43F2-8E7E-7262B0A5DBE9}" dt="2026-10-06T10:11:53.244" v="662" actId="113"/>
+          <ac:spMkLst>
+            <pc:docMk/>
+            <pc:sldMk cId="0" sldId="270"/>
+            <ac:spMk id="196" creationId="{00000000-0000-0000-0000-000000000000}"/>
+          </ac:spMkLst>
+        </pc:spChg>
+        <pc:spChg chg="mod">
+          <ac:chgData name="Caus, Danu" userId="76bbb7e8-a05c-4774-86b8-3bcd1c5d58b7" providerId="ADAL" clId="{25141FD5-A6FE-43F2-8E7E-7262B0A5DBE9}" dt="2026-10-06T10:02:57.295" v="649"/>
+          <ac:spMkLst>
+            <pc:docMk/>
+            <pc:sldMk cId="0" sldId="270"/>
+            <ac:spMk id="197" creationId="{00000000-0000-0000-0000-000000000000}"/>
+          </ac:spMkLst>
+        </pc:spChg>
+        <pc:spChg chg="mod">
+          <ac:chgData name="Caus, Danu" userId="76bbb7e8-a05c-4774-86b8-3bcd1c5d58b7" providerId="ADAL" clId="{25141FD5-A6FE-43F2-8E7E-7262B0A5DBE9}" dt="2026-10-06T10:02:57.295" v="649"/>
+          <ac:spMkLst>
+            <pc:docMk/>
+            <pc:sldMk cId="0" sldId="270"/>
+            <ac:spMk id="198" creationId="{00000000-0000-0000-0000-000000000000}"/>
+          </ac:spMkLst>
+        </pc:spChg>
+        <pc:grpChg chg="mod">
+          <ac:chgData name="Caus, Danu" userId="76bbb7e8-a05c-4774-86b8-3bcd1c5d58b7" providerId="ADAL" clId="{25141FD5-A6FE-43F2-8E7E-7262B0A5DBE9}" dt="2026-10-06T10:02:57.295" v="649"/>
+          <ac:grpSpMkLst>
+            <pc:docMk/>
+            <pc:sldMk cId="0" sldId="270"/>
+            <ac:grpSpMk id="193" creationId="{00000000-0000-0000-0000-000000000000}"/>
+          </ac:grpSpMkLst>
+        </pc:grpChg>
+        <pc:picChg chg="mod">
+          <ac:chgData name="Caus, Danu" userId="76bbb7e8-a05c-4774-86b8-3bcd1c5d58b7" providerId="ADAL" clId="{25141FD5-A6FE-43F2-8E7E-7262B0A5DBE9}" dt="2026-10-06T10:02:57.295" v="649"/>
+          <ac:picMkLst>
+            <pc:docMk/>
+            <pc:sldMk cId="0" sldId="270"/>
+            <ac:picMk id="194" creationId="{00000000-0000-0000-0000-000000000000}"/>
+          </ac:picMkLst>
+        </pc:picChg>
       </pc:sldChg>
       <pc:sldChg chg="modSp mod">
         <pc:chgData name="Caus, Danu" userId="76bbb7e8-a05c-4774-86b8-3bcd1c5d58b7" providerId="ADAL" clId="{25141FD5-A6FE-43F2-8E7E-7262B0A5DBE9}" dt="2026-10-02T09:44:29.766" v="30" actId="14100"/>
@@ -451,12 +583,136 @@
           </ac:picMkLst>
         </pc:picChg>
       </pc:sldChg>
+      <pc:sldChg chg="modSp mod modNotes">
+        <pc:chgData name="Caus, Danu" userId="76bbb7e8-a05c-4774-86b8-3bcd1c5d58b7" providerId="ADAL" clId="{25141FD5-A6FE-43F2-8E7E-7262B0A5DBE9}" dt="2026-10-06T10:33:41.116" v="664" actId="113"/>
+        <pc:sldMkLst>
+          <pc:docMk/>
+          <pc:sldMk cId="0" sldId="275"/>
+        </pc:sldMkLst>
+        <pc:spChg chg="mod">
+          <ac:chgData name="Caus, Danu" userId="76bbb7e8-a05c-4774-86b8-3bcd1c5d58b7" providerId="ADAL" clId="{25141FD5-A6FE-43F2-8E7E-7262B0A5DBE9}" dt="2026-10-06T10:33:41.116" v="664" actId="113"/>
+          <ac:spMkLst>
+            <pc:docMk/>
+            <pc:sldMk cId="0" sldId="275"/>
+            <ac:spMk id="255" creationId="{00000000-0000-0000-0000-000000000000}"/>
+          </ac:spMkLst>
+        </pc:spChg>
+      </pc:sldChg>
+      <pc:sldChg chg="addSp delSp modSp mod">
+        <pc:chgData name="Caus, Danu" userId="76bbb7e8-a05c-4774-86b8-3bcd1c5d58b7" providerId="ADAL" clId="{25141FD5-A6FE-43F2-8E7E-7262B0A5DBE9}" dt="2026-10-06T09:59:19.102" v="644" actId="1076"/>
+        <pc:sldMkLst>
+          <pc:docMk/>
+          <pc:sldMk cId="0" sldId="276"/>
+        </pc:sldMkLst>
+        <pc:spChg chg="add mod">
+          <ac:chgData name="Caus, Danu" userId="76bbb7e8-a05c-4774-86b8-3bcd1c5d58b7" providerId="ADAL" clId="{25141FD5-A6FE-43F2-8E7E-7262B0A5DBE9}" dt="2026-10-06T07:39:06.304" v="521" actId="1038"/>
+          <ac:spMkLst>
+            <pc:docMk/>
+            <pc:sldMk cId="0" sldId="276"/>
+            <ac:spMk id="4" creationId="{774D9699-BF2B-5C3C-506B-EBA8210A9075}"/>
+          </ac:spMkLst>
+        </pc:spChg>
+        <pc:spChg chg="add mod">
+          <ac:chgData name="Caus, Danu" userId="76bbb7e8-a05c-4774-86b8-3bcd1c5d58b7" providerId="ADAL" clId="{25141FD5-A6FE-43F2-8E7E-7262B0A5DBE9}" dt="2026-10-06T09:59:01.528" v="642" actId="14100"/>
+          <ac:spMkLst>
+            <pc:docMk/>
+            <pc:sldMk cId="0" sldId="276"/>
+            <ac:spMk id="8" creationId="{8704B088-3622-1EAA-BABD-63CCEB471346}"/>
+          </ac:spMkLst>
+        </pc:spChg>
+        <pc:spChg chg="add mod">
+          <ac:chgData name="Caus, Danu" userId="76bbb7e8-a05c-4774-86b8-3bcd1c5d58b7" providerId="ADAL" clId="{25141FD5-A6FE-43F2-8E7E-7262B0A5DBE9}" dt="2026-10-06T09:59:19.102" v="644" actId="1076"/>
+          <ac:spMkLst>
+            <pc:docMk/>
+            <pc:sldMk cId="0" sldId="276"/>
+            <ac:spMk id="9" creationId="{880AC039-1F32-F316-73AF-9EBA61FBF24C}"/>
+          </ac:spMkLst>
+        </pc:spChg>
+        <pc:spChg chg="mod">
+          <ac:chgData name="Caus, Danu" userId="76bbb7e8-a05c-4774-86b8-3bcd1c5d58b7" providerId="ADAL" clId="{25141FD5-A6FE-43F2-8E7E-7262B0A5DBE9}" dt="2026-10-06T07:40:20.511" v="530" actId="1076"/>
+          <ac:spMkLst>
+            <pc:docMk/>
+            <pc:sldMk cId="0" sldId="276"/>
+            <ac:spMk id="264" creationId="{00000000-0000-0000-0000-000000000000}"/>
+          </ac:spMkLst>
+        </pc:spChg>
+        <pc:spChg chg="mod">
+          <ac:chgData name="Caus, Danu" userId="76bbb7e8-a05c-4774-86b8-3bcd1c5d58b7" providerId="ADAL" clId="{25141FD5-A6FE-43F2-8E7E-7262B0A5DBE9}" dt="2026-10-06T07:40:01.259" v="528" actId="1076"/>
+          <ac:spMkLst>
+            <pc:docMk/>
+            <pc:sldMk cId="0" sldId="276"/>
+            <ac:spMk id="265" creationId="{00000000-0000-0000-0000-000000000000}"/>
+          </ac:spMkLst>
+        </pc:spChg>
+        <pc:picChg chg="add mod">
+          <ac:chgData name="Caus, Danu" userId="76bbb7e8-a05c-4774-86b8-3bcd1c5d58b7" providerId="ADAL" clId="{25141FD5-A6FE-43F2-8E7E-7262B0A5DBE9}" dt="2026-10-06T07:39:06.304" v="521" actId="1038"/>
+          <ac:picMkLst>
+            <pc:docMk/>
+            <pc:sldMk cId="0" sldId="276"/>
+            <ac:picMk id="3" creationId="{F4B5D532-EF32-2834-9F24-3664091799FD}"/>
+          </ac:picMkLst>
+        </pc:picChg>
+        <pc:picChg chg="add del">
+          <ac:chgData name="Caus, Danu" userId="76bbb7e8-a05c-4774-86b8-3bcd1c5d58b7" providerId="ADAL" clId="{25141FD5-A6FE-43F2-8E7E-7262B0A5DBE9}" dt="2026-10-06T07:35:20.202" v="330" actId="22"/>
+          <ac:picMkLst>
+            <pc:docMk/>
+            <pc:sldMk cId="0" sldId="276"/>
+            <ac:picMk id="6" creationId="{88EE3F85-CFA5-A1C7-C499-2CB778697AD3}"/>
+          </ac:picMkLst>
+        </pc:picChg>
+      </pc:sldChg>
+      <pc:sldChg chg="modSp mod modNotes">
+        <pc:chgData name="Caus, Danu" userId="76bbb7e8-a05c-4774-86b8-3bcd1c5d58b7" providerId="ADAL" clId="{25141FD5-A6FE-43F2-8E7E-7262B0A5DBE9}" dt="2026-10-06T07:26:36.878" v="290" actId="113"/>
+        <pc:sldMkLst>
+          <pc:docMk/>
+          <pc:sldMk cId="0" sldId="278"/>
+        </pc:sldMkLst>
+        <pc:spChg chg="mod">
+          <ac:chgData name="Caus, Danu" userId="76bbb7e8-a05c-4774-86b8-3bcd1c5d58b7" providerId="ADAL" clId="{25141FD5-A6FE-43F2-8E7E-7262B0A5DBE9}" dt="2026-10-06T07:26:09.856" v="283" actId="14100"/>
+          <ac:spMkLst>
+            <pc:docMk/>
+            <pc:sldMk cId="0" sldId="278"/>
+            <ac:spMk id="280" creationId="{00000000-0000-0000-0000-000000000000}"/>
+          </ac:spMkLst>
+        </pc:spChg>
+        <pc:spChg chg="mod">
+          <ac:chgData name="Caus, Danu" userId="76bbb7e8-a05c-4774-86b8-3bcd1c5d58b7" providerId="ADAL" clId="{25141FD5-A6FE-43F2-8E7E-7262B0A5DBE9}" dt="2026-10-06T07:26:36.878" v="290" actId="113"/>
+          <ac:spMkLst>
+            <pc:docMk/>
+            <pc:sldMk cId="0" sldId="278"/>
+            <ac:spMk id="281" creationId="{00000000-0000-0000-0000-000000000000}"/>
+          </ac:spMkLst>
+        </pc:spChg>
+      </pc:sldChg>
       <pc:sldChg chg="modSp mod">
-        <pc:chgData name="Caus, Danu" userId="76bbb7e8-a05c-4774-86b8-3bcd1c5d58b7" providerId="ADAL" clId="{25141FD5-A6FE-43F2-8E7E-7262B0A5DBE9}" dt="2026-10-02T08:37:05.451" v="1" actId="1076"/>
+        <pc:chgData name="Caus, Danu" userId="76bbb7e8-a05c-4774-86b8-3bcd1c5d58b7" providerId="ADAL" clId="{25141FD5-A6FE-43F2-8E7E-7262B0A5DBE9}" dt="2026-10-06T10:06:48.580" v="660" actId="20577"/>
+        <pc:sldMkLst>
+          <pc:docMk/>
+          <pc:sldMk cId="0" sldId="281"/>
+        </pc:sldMkLst>
+        <pc:spChg chg="mod">
+          <ac:chgData name="Caus, Danu" userId="76bbb7e8-a05c-4774-86b8-3bcd1c5d58b7" providerId="ADAL" clId="{25141FD5-A6FE-43F2-8E7E-7262B0A5DBE9}" dt="2026-10-06T10:06:48.580" v="660" actId="20577"/>
+          <ac:spMkLst>
+            <pc:docMk/>
+            <pc:sldMk cId="0" sldId="281"/>
+            <ac:spMk id="305" creationId="{00000000-0000-0000-0000-000000000000}"/>
+          </ac:spMkLst>
+        </pc:spChg>
+      </pc:sldChg>
+      <pc:sldChg chg="addSp modSp mod">
+        <pc:chgData name="Caus, Danu" userId="76bbb7e8-a05c-4774-86b8-3bcd1c5d58b7" providerId="ADAL" clId="{25141FD5-A6FE-43F2-8E7E-7262B0A5DBE9}" dt="2026-10-06T10:39:23.093" v="678"/>
         <pc:sldMkLst>
           <pc:docMk/>
           <pc:sldMk cId="0" sldId="282"/>
         </pc:sldMkLst>
+        <pc:spChg chg="add mod">
+          <ac:chgData name="Caus, Danu" userId="76bbb7e8-a05c-4774-86b8-3bcd1c5d58b7" providerId="ADAL" clId="{25141FD5-A6FE-43F2-8E7E-7262B0A5DBE9}" dt="2026-10-06T10:39:23.093" v="678"/>
+          <ac:spMkLst>
+            <pc:docMk/>
+            <pc:sldMk cId="0" sldId="282"/>
+            <ac:spMk id="2" creationId="{C9BC384C-383A-1391-4773-90402F2ED9DB}"/>
+          </ac:spMkLst>
+        </pc:spChg>
         <pc:spChg chg="mod">
           <ac:chgData name="Caus, Danu" userId="76bbb7e8-a05c-4774-86b8-3bcd1c5d58b7" providerId="ADAL" clId="{25141FD5-A6FE-43F2-8E7E-7262B0A5DBE9}" dt="2026-10-02T08:37:05.451" v="1" actId="1076"/>
           <ac:spMkLst>
@@ -941,8 +1197,8 @@
         </p:nvSpPr>
         <p:spPr>
           <a:xfrm>
-            <a:off x="381300" y="685800"/>
-            <a:ext cx="6096075" cy="3429000"/>
+            <a:off x="381000" y="685800"/>
+            <a:ext cx="6096000" cy="3429000"/>
           </a:xfrm>
           <a:custGeom>
             <a:avLst/>
@@ -1045,7 +1301,7 @@
         </p:nvSpPr>
         <p:spPr>
           <a:xfrm>
-            <a:off x="381300" y="685800"/>
+            <a:off x="381000" y="685800"/>
             <a:ext cx="6096000" cy="3429000"/>
           </a:xfrm>
           <a:custGeom>
@@ -1577,7 +1833,7 @@
         </p:nvSpPr>
         <p:spPr>
           <a:xfrm>
-            <a:off x="381300" y="685800"/>
+            <a:off x="381000" y="685800"/>
             <a:ext cx="6096000" cy="3429000"/>
           </a:xfrm>
           <a:custGeom>
@@ -2214,7 +2470,7 @@
         </p:nvSpPr>
         <p:spPr>
           <a:xfrm>
-            <a:off x="381300" y="685800"/>
+            <a:off x="381000" y="685800"/>
             <a:ext cx="6096000" cy="3429000"/>
           </a:xfrm>
           <a:custGeom>
@@ -2318,7 +2574,7 @@
         </p:nvSpPr>
         <p:spPr>
           <a:xfrm>
-            <a:off x="381300" y="685800"/>
+            <a:off x="381000" y="685800"/>
             <a:ext cx="6096000" cy="3429000"/>
           </a:xfrm>
           <a:custGeom>
@@ -2526,7 +2782,7 @@
         </p:nvSpPr>
         <p:spPr>
           <a:xfrm>
-            <a:off x="381300" y="685800"/>
+            <a:off x="381000" y="685800"/>
             <a:ext cx="6096000" cy="3429000"/>
           </a:xfrm>
           <a:custGeom>
@@ -2847,7 +3103,7 @@
         </p:nvSpPr>
         <p:spPr>
           <a:xfrm>
-            <a:off x="381300" y="685800"/>
+            <a:off x="381000" y="685800"/>
             <a:ext cx="6096000" cy="3429000"/>
           </a:xfrm>
           <a:custGeom>
@@ -8823,7 +9079,7 @@
         </p:nvSpPr>
         <p:spPr>
           <a:xfrm>
-            <a:off x="777300" y="1850100"/>
+            <a:off x="777300" y="1807016"/>
             <a:ext cx="7759500" cy="1443300"/>
           </a:xfrm>
           <a:prstGeom prst="rect">
@@ -8850,14 +9106,14 @@
               <a:buNone/>
             </a:pPr>
             <a:r>
-              <a:rPr lang="en" sz="3300" b="1">
+              <a:rPr lang="en" sz="3300" b="1" dirty="0">
                 <a:solidFill>
                   <a:schemeClr val="dk1"/>
                 </a:solidFill>
               </a:rPr>
               <a:t>How Do Language Models See Text?</a:t>
             </a:r>
-            <a:endParaRPr sz="3300" b="1">
+            <a:endParaRPr sz="3300" b="1" dirty="0">
               <a:solidFill>
                 <a:schemeClr val="dk1"/>
               </a:solidFill>
@@ -8874,14 +9130,14 @@
               <a:buNone/>
             </a:pPr>
             <a:r>
-              <a:rPr lang="en" sz="3300" b="1">
+              <a:rPr lang="en" sz="3300" b="1" dirty="0">
                 <a:solidFill>
                   <a:schemeClr val="dk1"/>
                 </a:solidFill>
               </a:rPr>
               <a:t>A Primer on Tokenization</a:t>
             </a:r>
-            <a:endParaRPr sz="3300" b="1">
+            <a:endParaRPr sz="3300" b="1" dirty="0">
               <a:solidFill>
                 <a:schemeClr val="dk1"/>
               </a:solidFill>
@@ -9099,14 +9355,14 @@
               <a:buNone/>
             </a:pPr>
             <a:r>
-              <a:rPr lang="en" sz="1500">
-                <a:solidFill>
-                  <a:schemeClr val="dk1"/>
-                </a:solidFill>
-              </a:rPr>
-              <a:t>English dominates online text, so both the LLM and its tokenizer see more of it, and English ends up tokenized more compactly. </a:t>
-            </a:r>
-            <a:endParaRPr sz="1500">
+              <a:rPr lang="en" sz="1500" dirty="0">
+                <a:solidFill>
+                  <a:schemeClr val="dk1"/>
+                </a:solidFill>
+              </a:rPr>
+              <a:t>English dominates online text, so both the LLM and its tokenizer see more of it, and English can end up being tokenized more compactly. </a:t>
+            </a:r>
+            <a:endParaRPr sz="1500" dirty="0">
               <a:solidFill>
                 <a:schemeClr val="dk1"/>
               </a:solidFill>
@@ -9150,7 +9406,7 @@
         </p:nvSpPr>
         <p:spPr>
           <a:xfrm>
-            <a:off x="1494275" y="3634675"/>
+            <a:off x="1599598" y="3467115"/>
             <a:ext cx="2157600" cy="354000"/>
           </a:xfrm>
           <a:prstGeom prst="rect">
@@ -10322,7 +10578,7 @@
               <a:buChar char="➢"/>
             </a:pPr>
             <a:r>
-              <a:rPr lang="en" sz="1300">
+              <a:rPr lang="en" sz="1300" dirty="0">
                 <a:solidFill>
                   <a:schemeClr val="dk1"/>
                 </a:solidFill>
@@ -10330,7 +10586,7 @@
               <a:t>10 identifies the </a:t>
             </a:r>
             <a:r>
-              <a:rPr lang="en" sz="1300" b="1">
+              <a:rPr lang="en" sz="1300" b="1" dirty="0">
                 <a:solidFill>
                   <a:schemeClr val="dk1"/>
                 </a:solidFill>
@@ -10338,14 +10594,14 @@
               <a:t>continuation </a:t>
             </a:r>
             <a:r>
-              <a:rPr lang="en" sz="1300">
+              <a:rPr lang="en" sz="1300" dirty="0">
                 <a:solidFill>
                   <a:schemeClr val="dk1"/>
                 </a:solidFill>
               </a:rPr>
               <a:t>byte.</a:t>
             </a:r>
-            <a:endParaRPr sz="1300">
+            <a:endParaRPr sz="1300" dirty="0">
               <a:solidFill>
                 <a:schemeClr val="dk1"/>
               </a:solidFill>
@@ -10807,8 +11063,8 @@
         </p:nvSpPr>
         <p:spPr>
           <a:xfrm>
-            <a:off x="330775" y="2764625"/>
-            <a:ext cx="8813100" cy="821496"/>
+            <a:off x="330774" y="2764625"/>
+            <a:ext cx="8894611" cy="821496"/>
           </a:xfrm>
           <a:prstGeom prst="rect">
             <a:avLst/>
@@ -10839,14 +11095,54 @@
             <a:r>
               <a:rPr lang="en" sz="1200" b="1" dirty="0">
                 <a:solidFill>
+                  <a:schemeClr val="accent1"/>
+                </a:solidFill>
+              </a:rPr>
+              <a:t>Hence, when you see lots of Unicode Replacement Characters like    , the LLM post-processing pipeline cannot decode the bytes correctly for the browser to render. </a:t>
+            </a:r>
+            <a:r>
+              <a:rPr lang="en-US" sz="1200" b="1" dirty="0">
+                <a:solidFill>
+                  <a:schemeClr val="accent1"/>
+                </a:solidFill>
+              </a:rPr>
+              <a:t>When decoding with </a:t>
+            </a:r>
+            <a:r>
+              <a:rPr lang="en-US" sz="1100" b="1" dirty="0">
+                <a:solidFill>
                   <a:srgbClr val="FF0000"/>
                 </a:solidFill>
               </a:rPr>
-              <a:t>Hence, when you see lots of Unicode Replacement Characters like    , the LLM post-processing pipeline cannot decode the bytes correctly for the browser to render. We join the bytes before decoding. If invalid byte sequences remain, errors="replace" displays     in their place: </a:t>
+              <a:t>errors="replace"</a:t>
+            </a:r>
+            <a:r>
+              <a:rPr lang="en-US" sz="1100" b="1" dirty="0">
+                <a:solidFill>
+                  <a:schemeClr val="accent1"/>
+                </a:solidFill>
+              </a:rPr>
+              <a:t>, </a:t>
+            </a:r>
+            <a:r>
+              <a:rPr lang="en-US" sz="1200" b="1" dirty="0">
+                <a:solidFill>
+                  <a:schemeClr val="accent1"/>
+                </a:solidFill>
+              </a:rPr>
+              <a:t>invalid UTF-8 sequences are replaced with</a:t>
+            </a:r>
+            <a:r>
+              <a:rPr lang="en" sz="1200" b="1" dirty="0">
+                <a:solidFill>
+                  <a:schemeClr val="accent1"/>
+                </a:solidFill>
+              </a:rPr>
+              <a:t> </a:t>
             </a:r>
             <a:endParaRPr sz="1200" b="1" dirty="0">
               <a:solidFill>
-                <a:srgbClr val="FF0000"/>
+                <a:schemeClr val="accent1"/>
               </a:solidFill>
             </a:endParaRPr>
           </a:p>
@@ -10953,7 +11249,7 @@
         </p:blipFill>
         <p:spPr>
           <a:xfrm>
-            <a:off x="2311532" y="3374393"/>
+            <a:off x="1421069" y="3385832"/>
             <a:ext cx="147658" cy="166711"/>
           </a:xfrm>
           <a:prstGeom prst="rect">
@@ -11044,7 +11340,7 @@
         </p:nvSpPr>
         <p:spPr>
           <a:xfrm>
-            <a:off x="604075" y="709462"/>
+            <a:off x="584850" y="611967"/>
             <a:ext cx="7974300" cy="520500"/>
           </a:xfrm>
           <a:prstGeom prst="rect">
@@ -11061,24 +11357,12 @@
           </a:bodyPr>
           <a:lstStyle/>
           <a:p>
-            <a:pPr marL="0" lvl="0" indent="0" algn="l" rtl="0">
-              <a:spcBef>
-                <a:spcPts val="0"/>
-              </a:spcBef>
-              <a:spcAft>
-                <a:spcPts val="0"/>
-              </a:spcAft>
-              <a:buNone/>
-            </a:pPr>
-            <a:r>
-              <a:rPr lang="en" sz="1600">
-                <a:solidFill>
-                  <a:schemeClr val="dk1"/>
-                </a:solidFill>
-              </a:rPr>
-              <a:t>Some merges should never take place. This can be enforced via regular expressions.</a:t>
-            </a:r>
-            <a:endParaRPr sz="1600">
+            <a:pPr lvl="0" algn="ctr"/>
+            <a:r>
+              <a:rPr lang="en-US" sz="1200" dirty="0"/>
+              <a:t>Some merges should never take place. For example, we might want to keep a word separate from the punctuation after it. Regular expressions let us specify which parts of the text should stay separate.</a:t>
+            </a:r>
+            <a:endParaRPr sz="1200" dirty="0">
               <a:solidFill>
                 <a:schemeClr val="dk1"/>
               </a:solidFill>
@@ -11770,18 +12054,24 @@
               <a:buNone/>
             </a:pPr>
             <a:r>
-              <a:rPr lang="en"/>
+              <a:rPr lang="en" dirty="0">
+                <a:hlinkClick r:id="rId4"/>
+              </a:rPr>
               <a:t>https://github.com/openai/</a:t>
             </a:r>
             <a:r>
-              <a:rPr lang="en" b="1"/>
+              <a:rPr lang="en" b="1" dirty="0">
+                <a:hlinkClick r:id="rId4"/>
+              </a:rPr>
               <a:t>gpt-2</a:t>
             </a:r>
             <a:r>
-              <a:rPr lang="en"/>
+              <a:rPr lang="en" dirty="0">
+                <a:hlinkClick r:id="rId4"/>
+              </a:rPr>
               <a:t>/blob/master/src/encoder.py</a:t>
             </a:r>
-            <a:endParaRPr/>
+            <a:endParaRPr dirty="0"/>
           </a:p>
         </p:txBody>
       </p:sp>
@@ -12047,7 +12337,7 @@
           <p:spPr>
             <a:xfrm>
               <a:off x="2580714" y="3272466"/>
-              <a:ext cx="5447400" cy="992700"/>
+              <a:ext cx="5447400" cy="1084882"/>
             </a:xfrm>
             <a:prstGeom prst="rect">
               <a:avLst/>
@@ -12063,16 +12353,10 @@
             </a:bodyPr>
             <a:lstStyle/>
             <a:p>
-              <a:pPr marL="457200" lvl="0" indent="-273050" algn="l" rtl="0">
+              <a:pPr marL="457200" lvl="0" indent="-273050">
                 <a:lnSpc>
                   <a:spcPct val="130000"/>
                 </a:lnSpc>
-                <a:spcBef>
-                  <a:spcPts val="0"/>
-                </a:spcBef>
-                <a:spcAft>
-                  <a:spcPts val="0"/>
-                </a:spcAft>
                 <a:buClr>
                   <a:srgbClr val="FF0000"/>
                 </a:buClr>
@@ -12080,7 +12364,7 @@
                 <a:buChar char="●"/>
               </a:pPr>
               <a:r>
-                <a:rPr lang="en" sz="700">
+                <a:rPr lang="en" sz="700" dirty="0">
                   <a:solidFill>
                     <a:srgbClr val="FF0000"/>
                   </a:solidFill>
@@ -12088,7 +12372,15 @@
                 <a:t>English contractions are now case-insensitive: both </a:t>
               </a:r>
               <a:r>
-                <a:rPr lang="en" sz="700">
+                <a:rPr lang="en" sz="800" b="1" dirty="0">
+                  <a:solidFill>
+                    <a:srgbClr val="FF9900"/>
+                  </a:solidFill>
+                </a:rPr>
+                <a:t>’</a:t>
+              </a:r>
+              <a:r>
+                <a:rPr lang="en" sz="700" dirty="0">
                   <a:solidFill>
                     <a:srgbClr val="FF0000"/>
                   </a:solidFill>
@@ -12097,10 +12389,10 @@
                   <a:cs typeface="Roboto Mono"/>
                   <a:sym typeface="Roboto Mono"/>
                 </a:rPr>
-                <a:t>'m</a:t>
+                <a:t>m</a:t>
               </a:r>
               <a:r>
-                <a:rPr lang="en" sz="700">
+                <a:rPr lang="en" sz="700" dirty="0">
                   <a:solidFill>
                     <a:srgbClr val="FF0000"/>
                   </a:solidFill>
@@ -12108,7 +12400,15 @@
                 <a:t> and </a:t>
               </a:r>
               <a:r>
-                <a:rPr lang="en" sz="700">
+                <a:rPr lang="en" sz="700" b="1" dirty="0">
+                  <a:solidFill>
+                    <a:srgbClr val="FF9900"/>
+                  </a:solidFill>
+                </a:rPr>
+                <a:t>’</a:t>
+              </a:r>
+              <a:r>
+                <a:rPr lang="en" sz="700" dirty="0">
                   <a:solidFill>
                     <a:srgbClr val="FF0000"/>
                   </a:solidFill>
@@ -12117,17 +12417,17 @@
                   <a:cs typeface="Roboto Mono"/>
                   <a:sym typeface="Roboto Mono"/>
                 </a:rPr>
-                <a:t>'M</a:t>
+                <a:t>M</a:t>
               </a:r>
               <a:r>
-                <a:rPr lang="en" sz="700">
+                <a:rPr lang="en" sz="700" dirty="0">
                   <a:solidFill>
                     <a:srgbClr val="FF0000"/>
                   </a:solidFill>
                 </a:rPr>
                 <a:t> are recognized</a:t>
               </a:r>
-              <a:endParaRPr sz="700">
+              <a:endParaRPr sz="700" dirty="0">
                 <a:solidFill>
                   <a:srgbClr val="FF0000"/>
                 </a:solidFill>
@@ -12151,7 +12451,7 @@
                 <a:buChar char="●"/>
               </a:pPr>
               <a:r>
-                <a:rPr lang="en" sz="700">
+                <a:rPr lang="en" sz="700" dirty="0">
                   <a:solidFill>
                     <a:srgbClr val="FF0000"/>
                   </a:solidFill>
@@ -12159,7 +12459,7 @@
                 <a:t>Numbers are split into groups of 1–3 digits: </a:t>
               </a:r>
               <a:r>
-                <a:rPr lang="en" sz="700">
+                <a:rPr lang="en" sz="700" dirty="0">
                   <a:solidFill>
                     <a:srgbClr val="FF0000"/>
                   </a:solidFill>
@@ -12171,7 +12471,7 @@
                 <a:t>12345</a:t>
               </a:r>
               <a:r>
-                <a:rPr lang="en" sz="700">
+                <a:rPr lang="en" sz="700" dirty="0">
                   <a:solidFill>
                     <a:srgbClr val="FF0000"/>
                   </a:solidFill>
@@ -12179,7 +12479,7 @@
                 <a:t> becomes </a:t>
               </a:r>
               <a:r>
-                <a:rPr lang="en" sz="700">
+                <a:rPr lang="en" sz="700" dirty="0">
                   <a:solidFill>
                     <a:srgbClr val="FF0000"/>
                   </a:solidFill>
@@ -12191,7 +12491,7 @@
                 <a:t>"123"</a:t>
               </a:r>
               <a:r>
-                <a:rPr lang="en" sz="700">
+                <a:rPr lang="en" sz="700" dirty="0">
                   <a:solidFill>
                     <a:srgbClr val="FF0000"/>
                   </a:solidFill>
@@ -12199,7 +12499,7 @@
                 <a:t> and </a:t>
               </a:r>
               <a:r>
-                <a:rPr lang="en" sz="700">
+                <a:rPr lang="en" sz="700" dirty="0">
                   <a:solidFill>
                     <a:srgbClr val="FF0000"/>
                   </a:solidFill>
@@ -12211,14 +12511,14 @@
                 <a:t>"45"</a:t>
               </a:r>
               <a:r>
-                <a:rPr lang="en" sz="700">
+                <a:rPr lang="en" sz="700" dirty="0">
                   <a:solidFill>
                     <a:srgbClr val="FF0000"/>
                   </a:solidFill>
                 </a:rPr>
                 <a:t>, instead of one chunk</a:t>
               </a:r>
-              <a:endParaRPr sz="700">
+              <a:endParaRPr sz="700" dirty="0">
                 <a:solidFill>
                   <a:srgbClr val="FF0000"/>
                 </a:solidFill>
@@ -12242,7 +12542,7 @@
                 <a:buChar char="●"/>
               </a:pPr>
               <a:r>
-                <a:rPr lang="en" sz="700">
+                <a:rPr lang="en" sz="700" dirty="0">
                   <a:solidFill>
                     <a:srgbClr val="FF0000"/>
                   </a:solidFill>
@@ -12250,7 +12550,7 @@
                 <a:t>Spaces before numbers are separated: </a:t>
               </a:r>
               <a:r>
-                <a:rPr lang="en" sz="700">
+                <a:rPr lang="en" sz="700" dirty="0">
                   <a:solidFill>
                     <a:srgbClr val="FF0000"/>
                   </a:solidFill>
@@ -12262,7 +12562,7 @@
                 <a:t>" 42"</a:t>
               </a:r>
               <a:r>
-                <a:rPr lang="en" sz="700">
+                <a:rPr lang="en" sz="700" dirty="0">
                   <a:solidFill>
                     <a:srgbClr val="FF0000"/>
                   </a:solidFill>
@@ -12270,7 +12570,7 @@
                 <a:t> becomes </a:t>
               </a:r>
               <a:r>
-                <a:rPr lang="en" sz="700">
+                <a:rPr lang="en" sz="700" dirty="0">
                   <a:solidFill>
                     <a:srgbClr val="FF0000"/>
                   </a:solidFill>
@@ -12282,7 +12582,7 @@
                 <a:t>" "</a:t>
               </a:r>
               <a:r>
-                <a:rPr lang="en" sz="700">
+                <a:rPr lang="en" sz="700" dirty="0">
                   <a:solidFill>
                     <a:srgbClr val="FF0000"/>
                   </a:solidFill>
@@ -12290,7 +12590,7 @@
                 <a:t> and </a:t>
               </a:r>
               <a:r>
-                <a:rPr lang="en" sz="700">
+                <a:rPr lang="en" sz="700" dirty="0">
                   <a:solidFill>
                     <a:srgbClr val="FF0000"/>
                   </a:solidFill>
@@ -12301,7 +12601,7 @@
                 </a:rPr>
                 <a:t>"42"</a:t>
               </a:r>
-              <a:endParaRPr sz="700">
+              <a:endParaRPr sz="700" dirty="0">
                 <a:solidFill>
                   <a:srgbClr val="FF0000"/>
                 </a:solidFill>
@@ -12325,7 +12625,7 @@
                 <a:buChar char="●"/>
               </a:pPr>
               <a:r>
-                <a:rPr lang="en" sz="700">
+                <a:rPr lang="en" sz="700" dirty="0">
                   <a:solidFill>
                     <a:srgbClr val="FF0000"/>
                   </a:solidFill>
@@ -12333,7 +12633,7 @@
                 <a:t>Words can include a preceding symbol: </a:t>
               </a:r>
               <a:r>
-                <a:rPr lang="en" sz="700">
+                <a:rPr lang="en" sz="700" dirty="0">
                   <a:solidFill>
                     <a:srgbClr val="FF0000"/>
                   </a:solidFill>
@@ -12345,7 +12645,7 @@
                 <a:t>"_hello"</a:t>
               </a:r>
               <a:r>
-                <a:rPr lang="en" sz="700">
+                <a:rPr lang="en" sz="700" dirty="0">
                   <a:solidFill>
                     <a:srgbClr val="FF0000"/>
                   </a:solidFill>
@@ -12353,7 +12653,7 @@
                 <a:t> can stay together, whereas GPT-2 separates </a:t>
               </a:r>
               <a:r>
-                <a:rPr lang="en" sz="700">
+                <a:rPr lang="en" sz="700" dirty="0">
                   <a:solidFill>
                     <a:srgbClr val="FF0000"/>
                   </a:solidFill>
@@ -12365,7 +12665,7 @@
                 <a:t>"_"</a:t>
               </a:r>
               <a:r>
-                <a:rPr lang="en" sz="700">
+                <a:rPr lang="en" sz="700" dirty="0">
                   <a:solidFill>
                     <a:srgbClr val="FF0000"/>
                   </a:solidFill>
@@ -12373,7 +12673,7 @@
                 <a:t> and </a:t>
               </a:r>
               <a:r>
-                <a:rPr lang="en" sz="700">
+                <a:rPr lang="en" sz="700" dirty="0">
                   <a:solidFill>
                     <a:srgbClr val="FF0000"/>
                   </a:solidFill>
@@ -12384,7 +12684,7 @@
                 </a:rPr>
                 <a:t>"hello"</a:t>
               </a:r>
-              <a:endParaRPr sz="700">
+              <a:endParaRPr sz="700" dirty="0">
                 <a:solidFill>
                   <a:srgbClr val="FF0000"/>
                 </a:solidFill>
@@ -12404,14 +12704,14 @@
                 <a:buNone/>
               </a:pPr>
               <a:r>
-                <a:rPr lang="en" sz="700">
+                <a:rPr lang="en" sz="700" dirty="0">
                   <a:solidFill>
                     <a:srgbClr val="FF0000"/>
                   </a:solidFill>
                 </a:rPr>
                 <a:t>Previously, only a preceding space could attach to a group of letters.</a:t>
               </a:r>
-              <a:endParaRPr sz="700">
+              <a:endParaRPr sz="700" dirty="0">
                 <a:solidFill>
                   <a:srgbClr val="FF0000"/>
                 </a:solidFill>
@@ -12435,7 +12735,7 @@
                 <a:buChar char="●"/>
               </a:pPr>
               <a:r>
-                <a:rPr lang="en" sz="700">
+                <a:rPr lang="en" sz="700" dirty="0">
                   <a:solidFill>
                     <a:srgbClr val="FF0000"/>
                   </a:solidFill>
@@ -12443,7 +12743,7 @@
                 <a:t>Punctuation can include following line breaks: </a:t>
               </a:r>
               <a:r>
-                <a:rPr lang="en" sz="700">
+                <a:rPr lang="en" sz="700" dirty="0">
                   <a:solidFill>
                     <a:srgbClr val="FF0000"/>
                   </a:solidFill>
@@ -12455,7 +12755,7 @@
                 <a:t>"!\n"</a:t>
               </a:r>
               <a:r>
-                <a:rPr lang="en" sz="700">
+                <a:rPr lang="en" sz="700" dirty="0">
                   <a:solidFill>
                     <a:srgbClr val="FF0000"/>
                   </a:solidFill>
@@ -12463,7 +12763,7 @@
                 <a:t> can stay together, whereas GPT-2 separates </a:t>
               </a:r>
               <a:r>
-                <a:rPr lang="en" sz="700">
+                <a:rPr lang="en" sz="700" dirty="0">
                   <a:solidFill>
                     <a:srgbClr val="FF0000"/>
                   </a:solidFill>
@@ -12475,7 +12775,7 @@
                 <a:t>"!"</a:t>
               </a:r>
               <a:r>
-                <a:rPr lang="en" sz="700">
+                <a:rPr lang="en" sz="700" dirty="0">
                   <a:solidFill>
                     <a:srgbClr val="FF0000"/>
                   </a:solidFill>
@@ -12483,7 +12783,7 @@
                 <a:t> and </a:t>
               </a:r>
               <a:r>
-                <a:rPr lang="en" sz="700">
+                <a:rPr lang="en" sz="700" dirty="0">
                   <a:solidFill>
                     <a:srgbClr val="FF0000"/>
                   </a:solidFill>
@@ -12494,7 +12794,7 @@
                 </a:rPr>
                 <a:t>"\n"</a:t>
               </a:r>
-              <a:endParaRPr sz="700">
+              <a:endParaRPr sz="700" dirty="0">
                 <a:solidFill>
                   <a:srgbClr val="FF0000"/>
                 </a:solidFill>
@@ -12511,7 +12811,7 @@
           <p:spPr>
             <a:xfrm>
               <a:off x="2161825" y="1757750"/>
-              <a:ext cx="5539800" cy="1139100"/>
+              <a:ext cx="5539800" cy="1446520"/>
             </a:xfrm>
             <a:prstGeom prst="rect">
               <a:avLst/>
@@ -12540,68 +12840,60 @@
                 <a:buNone/>
               </a:pPr>
               <a:r>
-                <a:rPr lang="en" sz="1000" b="1">
+                <a:rPr lang="en" sz="1000" b="1" dirty="0">
                   <a:solidFill>
                     <a:srgbClr val="FF9900"/>
                   </a:solidFill>
                 </a:rPr>
-                <a:t>Example text: “_hello I'M buying 12345!\n” where, “\n” represents a new line / line break.</a:t>
+                <a:t>Example text: “_hello I’M reading 12345!\n” where, “\n” represents a new line / line break.</a:t>
               </a:r>
-              <a:endParaRPr sz="1000" b="1">
+              <a:endParaRPr sz="1000" b="1" dirty="0">
                 <a:solidFill>
                   <a:srgbClr val="FF9900"/>
                 </a:solidFill>
               </a:endParaRPr>
             </a:p>
             <a:p>
-              <a:pPr marL="0" lvl="0" indent="0" algn="l" rtl="0">
+              <a:pPr lvl="0">
                 <a:lnSpc>
                   <a:spcPct val="50000"/>
                 </a:lnSpc>
                 <a:spcBef>
                   <a:spcPts val="1200"/>
                 </a:spcBef>
-                <a:spcAft>
-                  <a:spcPts val="0"/>
-                </a:spcAft>
-                <a:buNone/>
               </a:pPr>
               <a:r>
-                <a:rPr lang="en" sz="1000" b="1">
+                <a:rPr lang="en" sz="1000" b="1" dirty="0">
                   <a:solidFill>
                     <a:srgbClr val="FF9900"/>
                   </a:solidFill>
                 </a:rPr>
-                <a:t>GPT-2: ["_", "hello", " I", "'", "M", " buying", " 12345", "!", "\n"]</a:t>
+                <a:t>GPT-2: ["_", "hello", " I", "’", "M", " reading", " 12345", "!", "\n"]</a:t>
               </a:r>
-              <a:endParaRPr sz="1000" b="1">
+              <a:endParaRPr sz="1000" b="1" dirty="0">
                 <a:solidFill>
                   <a:srgbClr val="FF9900"/>
                 </a:solidFill>
               </a:endParaRPr>
             </a:p>
             <a:p>
-              <a:pPr marL="0" lvl="0" indent="0" algn="l" rtl="0">
+              <a:pPr lvl="0">
                 <a:lnSpc>
                   <a:spcPct val="50000"/>
                 </a:lnSpc>
                 <a:spcBef>
                   <a:spcPts val="1200"/>
                 </a:spcBef>
-                <a:spcAft>
-                  <a:spcPts val="0"/>
-                </a:spcAft>
-                <a:buNone/>
               </a:pPr>
               <a:r>
-                <a:rPr lang="en" sz="1000" b="1">
+                <a:rPr lang="en" sz="1000" b="1" dirty="0">
                   <a:solidFill>
                     <a:srgbClr val="FF9900"/>
                   </a:solidFill>
                 </a:rPr>
-                <a:t>New regex: ["_hello", " I", "'M", " buying", " ", "123", "45", "!\n"]</a:t>
+                <a:t>New regex: ["_hello", " I", "’M", " reading", " ", "123", "45", "!\n"]</a:t>
               </a:r>
-              <a:endParaRPr sz="1000" b="1">
+              <a:endParaRPr sz="1000" b="1" dirty="0">
                 <a:solidFill>
                   <a:srgbClr val="FF9900"/>
                 </a:solidFill>
@@ -12621,14 +12913,14 @@
                 <a:buNone/>
               </a:pPr>
               <a:r>
-                <a:rPr lang="en" sz="1000" b="1">
+                <a:rPr lang="en" sz="1000" b="1" dirty="0">
                   <a:solidFill>
                     <a:srgbClr val="FF9900"/>
                   </a:solidFill>
                 </a:rPr>
                 <a:t>The new regex keeps “_hello”, “'M”, and “!\n” together, but separates the space before the number and splits the digits into groups of up to three.</a:t>
               </a:r>
-              <a:endParaRPr sz="1000" b="1">
+              <a:endParaRPr sz="1000" b="1" dirty="0">
                 <a:solidFill>
                   <a:srgbClr val="FF9900"/>
                 </a:solidFill>
@@ -15567,14 +15859,24 @@
               <a:buNone/>
             </a:pPr>
             <a:r>
-              <a:rPr lang="en" b="1">
-                <a:solidFill>
-                  <a:schemeClr val="dk1"/>
-                </a:solidFill>
-              </a:rPr>
-              <a:t>https://github.com/openai/tiktoken#extending-tiktoken</a:t>
-            </a:r>
-            <a:endParaRPr b="1">
+              <a:rPr lang="en" dirty="0">
+                <a:solidFill>
+                  <a:schemeClr val="dk1"/>
+                </a:solidFill>
+                <a:hlinkClick r:id="rId4"/>
+              </a:rPr>
+              <a:t>https://github.com/openai/tiktoken</a:t>
+            </a:r>
+            <a:r>
+              <a:rPr lang="en" b="1" dirty="0">
+                <a:solidFill>
+                  <a:schemeClr val="dk1"/>
+                </a:solidFill>
+                <a:hlinkClick r:id="rId4"/>
+              </a:rPr>
+              <a:t>#extending-tiktoken</a:t>
+            </a:r>
+            <a:endParaRPr b="1" dirty="0">
               <a:solidFill>
                 <a:schemeClr val="dk1"/>
               </a:solidFill>
@@ -15784,14 +16086,14 @@
               <a:buNone/>
             </a:pPr>
             <a:r>
-              <a:rPr lang="en" sz="1800" b="1">
+              <a:rPr lang="en" sz="1800" b="1" dirty="0">
                 <a:solidFill>
                   <a:schemeClr val="dk1"/>
                 </a:solidFill>
               </a:rPr>
               <a:t>Adding New Tokens to a Pretrained Model</a:t>
             </a:r>
-            <a:endParaRPr sz="1800" b="1">
+            <a:endParaRPr sz="1800" b="1" dirty="0">
               <a:solidFill>
                 <a:schemeClr val="dk1"/>
               </a:solidFill>
@@ -15807,8 +16109,8 @@
         </p:nvSpPr>
         <p:spPr>
           <a:xfrm>
-            <a:off x="378900" y="1290804"/>
-            <a:ext cx="8386200" cy="2247000"/>
+            <a:off x="0" y="1255874"/>
+            <a:ext cx="6108766" cy="2126215"/>
           </a:xfrm>
           <a:prstGeom prst="rect">
             <a:avLst/>
@@ -15828,11 +16130,8 @@
               <a:lnSpc>
                 <a:spcPct val="150000"/>
               </a:lnSpc>
-              <a:spcBef>
-                <a:spcPts val="1000"/>
-              </a:spcBef>
-              <a:spcAft>
-                <a:spcPts val="0"/>
+              <a:spcAft>
+                <a:spcPts val="1800"/>
               </a:spcAft>
               <a:buClr>
                 <a:schemeClr val="dk1"/>
@@ -15841,14 +16140,14 @@
               <a:buAutoNum type="arabicPeriod"/>
             </a:pPr>
             <a:r>
-              <a:rPr lang="en" sz="1800">
+              <a:rPr lang="en" dirty="0">
                 <a:solidFill>
                   <a:schemeClr val="dk1"/>
                 </a:solidFill>
               </a:rPr>
               <a:t>Add the new token to the tokenizer.</a:t>
             </a:r>
-            <a:endParaRPr sz="1800">
+            <a:endParaRPr dirty="0">
               <a:solidFill>
                 <a:schemeClr val="dk1"/>
               </a:solidFill>
@@ -15859,11 +16158,8 @@
               <a:lnSpc>
                 <a:spcPct val="150000"/>
               </a:lnSpc>
-              <a:spcBef>
-                <a:spcPts val="1000"/>
-              </a:spcBef>
-              <a:spcAft>
-                <a:spcPts val="0"/>
+              <a:spcAft>
+                <a:spcPts val="1800"/>
               </a:spcAft>
               <a:buClr>
                 <a:schemeClr val="dk1"/>
@@ -15872,14 +16168,14 @@
               <a:buAutoNum type="arabicPeriod"/>
             </a:pPr>
             <a:r>
-              <a:rPr lang="en" sz="1800">
-                <a:solidFill>
-                  <a:schemeClr val="dk1"/>
-                </a:solidFill>
-              </a:rPr>
-              <a:t>Expand the input embedding matrix and output vocabulary projection.</a:t>
-            </a:r>
-            <a:endParaRPr sz="1800">
+              <a:rPr lang="en" dirty="0">
+                <a:solidFill>
+                  <a:schemeClr val="dk1"/>
+                </a:solidFill>
+              </a:rPr>
+              <a:t>Expand the input embedding matrix and output vocabulary projection. </a:t>
+            </a:r>
+            <a:endParaRPr dirty="0">
               <a:solidFill>
                 <a:schemeClr val="dk1"/>
               </a:solidFill>
@@ -15890,11 +16186,8 @@
               <a:lnSpc>
                 <a:spcPct val="150000"/>
               </a:lnSpc>
-              <a:spcBef>
-                <a:spcPts val="1000"/>
-              </a:spcBef>
-              <a:spcAft>
-                <a:spcPts val="0"/>
+              <a:spcAft>
+                <a:spcPts val="1800"/>
               </a:spcAft>
               <a:buClr>
                 <a:schemeClr val="dk1"/>
@@ -15903,14 +16196,14 @@
               <a:buAutoNum type="arabicPeriod"/>
             </a:pPr>
             <a:r>
-              <a:rPr lang="en" sz="1800">
+              <a:rPr lang="en" dirty="0">
                 <a:solidFill>
                   <a:schemeClr val="dk1"/>
                 </a:solidFill>
               </a:rPr>
               <a:t>Initialize the new parameters.</a:t>
             </a:r>
-            <a:endParaRPr sz="1800">
+            <a:endParaRPr dirty="0">
               <a:solidFill>
                 <a:schemeClr val="dk1"/>
               </a:solidFill>
@@ -15921,11 +16214,8 @@
               <a:lnSpc>
                 <a:spcPct val="150000"/>
               </a:lnSpc>
-              <a:spcBef>
-                <a:spcPts val="1000"/>
-              </a:spcBef>
-              <a:spcAft>
-                <a:spcPts val="0"/>
+              <a:spcAft>
+                <a:spcPts val="1800"/>
               </a:spcAft>
               <a:buClr>
                 <a:schemeClr val="dk1"/>
@@ -15934,14 +16224,14 @@
               <a:buAutoNum type="arabicPeriod"/>
             </a:pPr>
             <a:r>
-              <a:rPr lang="en" sz="1800">
+              <a:rPr lang="en" dirty="0">
                 <a:solidFill>
                   <a:schemeClr val="dk1"/>
                 </a:solidFill>
               </a:rPr>
               <a:t>Fine-tune on examples containing the new token.</a:t>
             </a:r>
-            <a:endParaRPr sz="1800">
+            <a:endParaRPr dirty="0">
               <a:solidFill>
                 <a:schemeClr val="dk1"/>
               </a:solidFill>
@@ -15957,7 +16247,7 @@
         </p:nvSpPr>
         <p:spPr>
           <a:xfrm>
-            <a:off x="224550" y="3781013"/>
+            <a:off x="224539" y="3978333"/>
             <a:ext cx="8694900" cy="639000"/>
           </a:xfrm>
           <a:prstGeom prst="rect">
@@ -15987,7 +16277,7 @@
               <a:buNone/>
             </a:pPr>
             <a:r>
-              <a:rPr lang="en" sz="1500">
+              <a:rPr lang="en" sz="1500" dirty="0">
                 <a:solidFill>
                   <a:schemeClr val="accent1"/>
                 </a:solidFill>
@@ -15995,7 +16285,7 @@
               <a:t>Adding special tokens can support adapting a </a:t>
             </a:r>
             <a:r>
-              <a:rPr lang="en" sz="1500" b="1">
+              <a:rPr lang="en" sz="1500" b="1" dirty="0">
                 <a:solidFill>
                   <a:schemeClr val="accent1"/>
                 </a:solidFill>
@@ -16003,7 +16293,7 @@
               <a:t>base model for chat</a:t>
             </a:r>
             <a:r>
-              <a:rPr lang="en" sz="1500">
+              <a:rPr lang="en" sz="1500" dirty="0">
                 <a:solidFill>
                   <a:schemeClr val="accent1"/>
                 </a:solidFill>
@@ -16011,7 +16301,7 @@
               <a:t> or introducing </a:t>
             </a:r>
             <a:r>
-              <a:rPr lang="en" sz="1500" b="1">
+              <a:rPr lang="en" sz="1500" b="1" dirty="0">
                 <a:solidFill>
                   <a:schemeClr val="accent1"/>
                 </a:solidFill>
@@ -16019,7 +16309,7 @@
               <a:t>tool-use formats</a:t>
             </a:r>
             <a:r>
-              <a:rPr lang="en" sz="1500">
+              <a:rPr lang="en" sz="1500" dirty="0">
                 <a:solidFill>
                   <a:schemeClr val="accent1"/>
                 </a:solidFill>
@@ -16027,7 +16317,7 @@
               <a:t> in chat and coding models. </a:t>
             </a:r>
             <a:r>
-              <a:rPr lang="en" sz="1500" b="1">
+              <a:rPr lang="en" sz="1500" b="1" dirty="0">
                 <a:solidFill>
                   <a:schemeClr val="accent1"/>
                 </a:solidFill>
@@ -16035,14 +16325,14 @@
               <a:t>Fine-tuning</a:t>
             </a:r>
             <a:r>
-              <a:rPr lang="en" sz="1500">
+              <a:rPr lang="en" sz="1500" dirty="0">
                 <a:solidFill>
                   <a:schemeClr val="accent1"/>
                 </a:solidFill>
               </a:rPr>
               <a:t> teaches the model to interpret and generate these formats.</a:t>
             </a:r>
-            <a:endParaRPr sz="1500">
+            <a:endParaRPr sz="1500" dirty="0">
               <a:solidFill>
                 <a:schemeClr val="accent1"/>
               </a:solidFill>
@@ -16089,6 +16379,162 @@
               <a:t>21</a:t>
             </a:fld>
             <a:endParaRPr/>
+          </a:p>
+        </p:txBody>
+      </p:sp>
+      <p:pic>
+        <p:nvPicPr>
+          <p:cNvPr id="3" name="Picture 2">
+            <a:extLst>
+              <a:ext uri="{FF2B5EF4-FFF2-40B4-BE49-F238E27FC236}">
+                <a16:creationId xmlns:a16="http://schemas.microsoft.com/office/drawing/2014/main" id="{F4B5D532-EF32-2834-9F24-3664091799FD}"/>
+              </a:ext>
+            </a:extLst>
+          </p:cNvPr>
+          <p:cNvPicPr>
+            <a:picLocks noChangeAspect="1"/>
+          </p:cNvPicPr>
+          <p:nvPr/>
+        </p:nvPicPr>
+        <p:blipFill>
+          <a:blip r:embed="rId3"/>
+          <a:stretch>
+            <a:fillRect/>
+          </a:stretch>
+        </p:blipFill>
+        <p:spPr>
+          <a:xfrm>
+            <a:off x="6262365" y="856951"/>
+            <a:ext cx="1471103" cy="3000322"/>
+          </a:xfrm>
+          <a:prstGeom prst="rect">
+            <a:avLst/>
+          </a:prstGeom>
+        </p:spPr>
+      </p:pic>
+      <p:sp>
+        <p:nvSpPr>
+          <p:cNvPr id="4" name="TextBox 3">
+            <a:extLst>
+              <a:ext uri="{FF2B5EF4-FFF2-40B4-BE49-F238E27FC236}">
+                <a16:creationId xmlns:a16="http://schemas.microsoft.com/office/drawing/2014/main" id="{774D9699-BF2B-5C3C-506B-EBA8210A9075}"/>
+              </a:ext>
+            </a:extLst>
+          </p:cNvPr>
+          <p:cNvSpPr txBox="1"/>
+          <p:nvPr/>
+        </p:nvSpPr>
+        <p:spPr>
+          <a:xfrm>
+            <a:off x="7698194" y="1455381"/>
+            <a:ext cx="1277552" cy="215444"/>
+          </a:xfrm>
+          <a:prstGeom prst="rect">
+            <a:avLst/>
+          </a:prstGeom>
+          <a:noFill/>
+        </p:spPr>
+        <p:txBody>
+          <a:bodyPr wrap="square" rtlCol="0">
+            <a:spAutoFit/>
+          </a:bodyPr>
+          <a:lstStyle/>
+          <a:p>
+            <a:r>
+              <a:rPr lang="en-US" sz="800" dirty="0"/>
+              <a:t>A vector for new token</a:t>
+            </a:r>
+          </a:p>
+        </p:txBody>
+      </p:sp>
+      <p:sp>
+        <p:nvSpPr>
+          <p:cNvPr id="8" name="TextBox 7">
+            <a:extLst>
+              <a:ext uri="{FF2B5EF4-FFF2-40B4-BE49-F238E27FC236}">
+                <a16:creationId xmlns:a16="http://schemas.microsoft.com/office/drawing/2014/main" id="{8704B088-3622-1EAA-BABD-63CCEB471346}"/>
+              </a:ext>
+            </a:extLst>
+          </p:cNvPr>
+          <p:cNvSpPr txBox="1"/>
+          <p:nvPr/>
+        </p:nvSpPr>
+        <p:spPr>
+          <a:xfrm>
+            <a:off x="7698194" y="3074633"/>
+            <a:ext cx="1322964" cy="584775"/>
+          </a:xfrm>
+          <a:prstGeom prst="rect">
+            <a:avLst/>
+          </a:prstGeom>
+          <a:noFill/>
+        </p:spPr>
+        <p:txBody>
+          <a:bodyPr wrap="square" rtlCol="0">
+            <a:spAutoFit/>
+          </a:bodyPr>
+          <a:lstStyle/>
+          <a:p>
+            <a:r>
+              <a:rPr lang="en-US" sz="800" dirty="0"/>
+              <a:t>Weights for predicting the new token. Note that </a:t>
+            </a:r>
+            <a:r>
+              <a:rPr lang="en-US" sz="800" i="1" dirty="0"/>
+              <a:t>V</a:t>
+            </a:r>
+            <a:r>
+              <a:rPr lang="en-US" sz="800" dirty="0"/>
+              <a:t> is the vocabulary size and </a:t>
+            </a:r>
+            <a:r>
+              <a:rPr lang="en-US" sz="800" i="1" dirty="0"/>
+              <a:t>d</a:t>
+            </a:r>
+            <a:r>
+              <a:rPr lang="en-US" sz="800" dirty="0"/>
+              <a:t> is the vector size.</a:t>
+            </a:r>
+          </a:p>
+        </p:txBody>
+      </p:sp>
+      <p:sp>
+        <p:nvSpPr>
+          <p:cNvPr id="9" name="TextBox 8">
+            <a:extLst>
+              <a:ext uri="{FF2B5EF4-FFF2-40B4-BE49-F238E27FC236}">
+                <a16:creationId xmlns:a16="http://schemas.microsoft.com/office/drawing/2014/main" id="{880AC039-1F32-F316-73AF-9EBA61FBF24C}"/>
+              </a:ext>
+            </a:extLst>
+          </p:cNvPr>
+          <p:cNvSpPr txBox="1"/>
+          <p:nvPr/>
+        </p:nvSpPr>
+        <p:spPr>
+          <a:xfrm>
+            <a:off x="7601418" y="1897737"/>
+            <a:ext cx="1471103" cy="738664"/>
+          </a:xfrm>
+          <a:prstGeom prst="rect">
+            <a:avLst/>
+          </a:prstGeom>
+          <a:noFill/>
+        </p:spPr>
+        <p:txBody>
+          <a:bodyPr wrap="square" rtlCol="0">
+            <a:spAutoFit/>
+          </a:bodyPr>
+          <a:lstStyle/>
+          <a:p>
+            <a:pPr algn="ctr"/>
+            <a:r>
+              <a:rPr lang="en-US" dirty="0">
+                <a:solidFill>
+                  <a:srgbClr val="FF0000"/>
+                </a:solidFill>
+              </a:rPr>
+              <a:t>We initialize the new rows and then fine-tune.</a:t>
+            </a:r>
           </a:p>
         </p:txBody>
       </p:sp>
@@ -16626,8 +17072,8 @@
         </p:nvSpPr>
         <p:spPr>
           <a:xfrm>
-            <a:off x="2696140" y="0"/>
-            <a:ext cx="3557100" cy="472500"/>
+            <a:off x="2049021" y="0"/>
+            <a:ext cx="5098619" cy="472500"/>
           </a:xfrm>
           <a:prstGeom prst="rect">
             <a:avLst/>
@@ -16643,24 +17089,32 @@
           </a:bodyPr>
           <a:lstStyle/>
           <a:p>
-            <a:pPr marL="0" lvl="0" indent="0" algn="l" rtl="0">
-              <a:spcBef>
-                <a:spcPts val="0"/>
-              </a:spcBef>
-              <a:spcAft>
-                <a:spcPts val="0"/>
-              </a:spcAft>
-              <a:buNone/>
-            </a:pPr>
-            <a:r>
-              <a:rPr lang="en" sz="1800" b="1">
-                <a:solidFill>
-                  <a:schemeClr val="dk1"/>
-                </a:solidFill>
-              </a:rPr>
-              <a:t>Token Types in SentencePiece </a:t>
-            </a:r>
-            <a:endParaRPr sz="1800" b="1">
+            <a:pPr lvl="0"/>
+            <a:r>
+              <a:rPr lang="en-US" sz="1800" b="1" dirty="0">
+                <a:solidFill>
+                  <a:schemeClr val="dk1"/>
+                </a:solidFill>
+              </a:rPr>
+              <a:t>What Is in a </a:t>
+            </a:r>
+            <a:r>
+              <a:rPr lang="en-US" sz="1800" b="1" dirty="0" err="1">
+                <a:solidFill>
+                  <a:schemeClr val="dk1"/>
+                </a:solidFill>
+              </a:rPr>
+              <a:t>SentencePiece</a:t>
+            </a:r>
+            <a:r>
+              <a:rPr lang="en-US" sz="1800" b="1" dirty="0">
+                <a:solidFill>
+                  <a:schemeClr val="dk1"/>
+                </a:solidFill>
+              </a:rPr>
+              <a:t> BPE Vocabulary?</a:t>
+            </a:r>
+            <a:endParaRPr sz="1800" b="1" dirty="0">
               <a:solidFill>
                 <a:schemeClr val="dk1"/>
               </a:solidFill>
@@ -16710,7 +17164,7 @@
               <a:buAutoNum type="arabicPeriod"/>
             </a:pPr>
             <a:r>
-              <a:rPr lang="en" sz="1600" b="1">
+              <a:rPr lang="en" sz="1600" b="1" dirty="0">
                 <a:solidFill>
                   <a:schemeClr val="dk1"/>
                 </a:solidFill>
@@ -16718,7 +17172,7 @@
               <a:t>Special Tokens</a:t>
             </a:r>
             <a:r>
-              <a:rPr lang="en" sz="1600">
+              <a:rPr lang="en" sz="1600" dirty="0">
                 <a:solidFill>
                   <a:schemeClr val="dk1"/>
                 </a:solidFill>
@@ -16726,7 +17180,7 @@
               <a:t> → Reserved tokens with predefined functions, e.g. </a:t>
             </a:r>
             <a:r>
-              <a:rPr lang="en" sz="1600" b="1">
+              <a:rPr lang="en" sz="1600" b="1" dirty="0">
                 <a:solidFill>
                   <a:schemeClr val="dk1"/>
                 </a:solidFill>
@@ -16734,14 +17188,14 @@
               <a:t>&lt;unk&gt; for unknown tokens</a:t>
             </a:r>
             <a:r>
-              <a:rPr lang="en" sz="1600">
+              <a:rPr lang="en" sz="1600" dirty="0">
                 <a:solidFill>
                   <a:schemeClr val="dk1"/>
                 </a:solidFill>
               </a:rPr>
               <a:t>, &lt;s&gt; for start of sentence, &lt;/s&gt; for end of sentence, and optionally &lt;pad&gt; for padding.</a:t>
             </a:r>
-            <a:endParaRPr sz="1600">
+            <a:endParaRPr sz="1600" dirty="0">
               <a:solidFill>
                 <a:schemeClr val="dk1"/>
               </a:solidFill>
@@ -16765,7 +17219,7 @@
               <a:buAutoNum type="arabicPeriod"/>
             </a:pPr>
             <a:r>
-              <a:rPr lang="en" sz="1600" b="1">
+              <a:rPr lang="en" sz="1600" b="1" dirty="0">
                 <a:solidFill>
                   <a:schemeClr val="dk1"/>
                 </a:solidFill>
@@ -16773,7 +17227,7 @@
               <a:t>Byte Tokens</a:t>
             </a:r>
             <a:r>
-              <a:rPr lang="en" sz="1600">
+              <a:rPr lang="en" sz="1600" dirty="0">
                 <a:solidFill>
                   <a:schemeClr val="dk1"/>
                 </a:solidFill>
@@ -16781,7 +17235,7 @@
               <a:t> → Tokens representing individual bytes, used as a fallback for characters not covered by the normal vocabulary when </a:t>
             </a:r>
             <a:r>
-              <a:rPr lang="en" sz="1600" b="1">
+              <a:rPr lang="en" sz="1600" b="1" dirty="0">
                 <a:solidFill>
                   <a:schemeClr val="dk1"/>
                 </a:solidFill>
@@ -16789,14 +17243,14 @@
               <a:t>byte_fallback = True</a:t>
             </a:r>
             <a:r>
-              <a:rPr lang="en" sz="1600">
+              <a:rPr lang="en" sz="1600" dirty="0">
                 <a:solidFill>
                   <a:schemeClr val="dk1"/>
                 </a:solidFill>
               </a:rPr>
               <a:t> </a:t>
             </a:r>
-            <a:endParaRPr sz="1600">
+            <a:endParaRPr sz="1600" dirty="0">
               <a:solidFill>
                 <a:schemeClr val="dk1"/>
               </a:solidFill>
@@ -16820,7 +17274,7 @@
               <a:buAutoNum type="arabicPeriod"/>
             </a:pPr>
             <a:r>
-              <a:rPr lang="en" sz="1600" b="1">
+              <a:rPr lang="en" sz="1600" b="1" dirty="0">
                 <a:solidFill>
                   <a:schemeClr val="dk1"/>
                 </a:solidFill>
@@ -16828,7 +17282,7 @@
               <a:t>Merge Tokens</a:t>
             </a:r>
             <a:r>
-              <a:rPr lang="en" sz="1600">
+              <a:rPr lang="en" sz="1600" dirty="0">
                 <a:solidFill>
                   <a:schemeClr val="dk1"/>
                 </a:solidFill>
@@ -16836,7 +17290,7 @@
               <a:t> → </a:t>
             </a:r>
             <a:r>
-              <a:rPr lang="en" sz="1600" b="1">
+              <a:rPr lang="en" sz="1600" b="1" dirty="0">
                 <a:solidFill>
                   <a:schemeClr val="dk1"/>
                 </a:solidFill>
@@ -16844,7 +17298,7 @@
               <a:t>Subword tokens</a:t>
             </a:r>
             <a:r>
-              <a:rPr lang="en" sz="1600">
+              <a:rPr lang="en" sz="1600" dirty="0">
                 <a:solidFill>
                   <a:schemeClr val="dk1"/>
                 </a:solidFill>
@@ -16852,7 +17306,7 @@
               <a:t> learned by repeatedly </a:t>
             </a:r>
             <a:r>
-              <a:rPr lang="en" sz="1600" b="1">
+              <a:rPr lang="en" sz="1600" b="1" dirty="0">
                 <a:solidFill>
                   <a:schemeClr val="dk1"/>
                 </a:solidFill>
@@ -16860,30 +17314,24 @@
               <a:t>merging </a:t>
             </a:r>
             <a:r>
-              <a:rPr lang="en" sz="1600">
+              <a:rPr lang="en" sz="1600" dirty="0">
                 <a:solidFill>
                   <a:schemeClr val="dk1"/>
                 </a:solidFill>
               </a:rPr>
               <a:t>frequently occurring neighboring symbols during BPE training. </a:t>
             </a:r>
-            <a:endParaRPr sz="1600">
+            <a:endParaRPr sz="1600" dirty="0">
               <a:solidFill>
                 <a:schemeClr val="dk1"/>
               </a:solidFill>
             </a:endParaRPr>
           </a:p>
           <a:p>
-            <a:pPr marL="457200" lvl="0" indent="-330200" algn="l" rtl="0">
-              <a:lnSpc>
-                <a:spcPct val="115000"/>
-              </a:lnSpc>
+            <a:pPr marL="457200" lvl="0" indent="-330200">
               <a:spcBef>
                 <a:spcPts val="1000"/>
               </a:spcBef>
-              <a:spcAft>
-                <a:spcPts val="0"/>
-              </a:spcAft>
               <a:buClr>
                 <a:schemeClr val="dk1"/>
               </a:buClr>
@@ -16891,23 +17339,19 @@
               <a:buAutoNum type="arabicPeriod"/>
             </a:pPr>
             <a:r>
-              <a:rPr lang="en" sz="1600" b="1">
-                <a:solidFill>
-                  <a:schemeClr val="dk1"/>
-                </a:solidFill>
-              </a:rPr>
-              <a:t>Individual Codepoint Tokens</a:t>
-            </a:r>
-            <a:r>
-              <a:rPr lang="en" sz="1600">
-                <a:solidFill>
-                  <a:schemeClr val="dk1"/>
-                </a:solidFill>
-              </a:rPr>
-              <a:t> → Tokens representing individual Unicode characters retained according to the specified character_coverage. If a codepoint is too rare to fall within the cumulative character coverage specified by character_coverage, it is not added to the vocabulary, e.g. </a:t>
-            </a:r>
-            <a:r>
-              <a:rPr lang="en" sz="1600" b="1">
+              <a:rPr lang="en-US" sz="1600" b="1" dirty="0"/>
+              <a:t>Single-character tokens </a:t>
+            </a:r>
+            <a:r>
+              <a:rPr lang="en" sz="1600" dirty="0">
+                <a:solidFill>
+                  <a:schemeClr val="dk1"/>
+                </a:solidFill>
+              </a:rPr>
+              <a:t>→ Tokens representing individual Unicode characters retained according to the specified character_coverage. If a codepoint is too rare to fall within the cumulative character coverage specified by character_coverage, it is not added to the vocabulary, e.g. </a:t>
+            </a:r>
+            <a:r>
+              <a:rPr lang="en" sz="1600" b="1" dirty="0">
                 <a:solidFill>
                   <a:schemeClr val="dk1"/>
                 </a:solidFill>
@@ -16915,14 +17359,14 @@
               <a:t>character_coverage = 0.995</a:t>
             </a:r>
             <a:r>
-              <a:rPr lang="en" sz="1600">
+              <a:rPr lang="en" sz="1600" dirty="0">
                 <a:solidFill>
                   <a:schemeClr val="dk1"/>
                 </a:solidFill>
               </a:rPr>
               <a:t> </a:t>
             </a:r>
-            <a:endParaRPr sz="1600">
+            <a:endParaRPr sz="1600" dirty="0">
               <a:solidFill>
                 <a:schemeClr val="dk1"/>
               </a:solidFill>
@@ -19014,14 +19458,14 @@
               <a:buNone/>
             </a:pPr>
             <a:r>
-              <a:rPr lang="en" sz="1800" b="1">
+              <a:rPr lang="en" sz="1800" b="1" dirty="0">
                 <a:solidFill>
                   <a:schemeClr val="dk1"/>
                 </a:solidFill>
               </a:rPr>
               <a:t>Takeaways</a:t>
             </a:r>
-            <a:endParaRPr sz="1800" b="1">
+            <a:endParaRPr sz="1800" b="1" dirty="0">
               <a:solidFill>
                 <a:schemeClr val="dk1"/>
               </a:solidFill>
@@ -19067,7 +19511,7 @@
               <a:rPr lang="en"/>
               <a:t>26</a:t>
             </a:fld>
-            <a:endParaRPr/>
+            <a:endParaRPr dirty="0"/>
           </a:p>
         </p:txBody>
       </p:sp>
@@ -19079,8 +19523,8 @@
         </p:nvSpPr>
         <p:spPr>
           <a:xfrm>
-            <a:off x="248550" y="625950"/>
-            <a:ext cx="8646900" cy="3532500"/>
+            <a:off x="191100" y="932346"/>
+            <a:ext cx="8646900" cy="3493234"/>
           </a:xfrm>
           <a:prstGeom prst="rect">
             <a:avLst/>
@@ -19097,14 +19541,8 @@
           <a:lstStyle/>
           <a:p>
             <a:pPr marL="457200" lvl="0" indent="-323850" algn="l" rtl="0">
-              <a:lnSpc>
-                <a:spcPct val="150000"/>
-              </a:lnSpc>
-              <a:spcBef>
+              <a:spcAft>
                 <a:spcPts val="1200"/>
-              </a:spcBef>
-              <a:spcAft>
-                <a:spcPts val="0"/>
               </a:spcAft>
               <a:buClr>
                 <a:schemeClr val="dk1"/>
@@ -19113,7 +19551,7 @@
               <a:buChar char="➢"/>
             </a:pPr>
             <a:r>
-              <a:rPr lang="en" sz="1500" b="1">
+              <a:rPr lang="en" sz="1500" b="1" dirty="0">
                 <a:solidFill>
                   <a:schemeClr val="dk1"/>
                 </a:solidFill>
@@ -19121,14 +19559,14 @@
               <a:t>Tokens are the model’s units of text.</a:t>
             </a:r>
             <a:r>
-              <a:rPr lang="en" sz="1500">
+              <a:rPr lang="en" sz="1500" dirty="0">
                 <a:solidFill>
                   <a:schemeClr val="dk1"/>
                 </a:solidFill>
               </a:rPr>
               <a:t> The tokenizer converts text into a sequence of numerical IDs.</a:t>
             </a:r>
-            <a:endParaRPr sz="1500">
+            <a:endParaRPr sz="1500" dirty="0">
               <a:solidFill>
                 <a:schemeClr val="dk1"/>
               </a:solidFill>
@@ -19136,14 +19574,8 @@
           </a:p>
           <a:p>
             <a:pPr marL="457200" lvl="0" indent="-323850" algn="l" rtl="0">
-              <a:lnSpc>
-                <a:spcPct val="150000"/>
-              </a:lnSpc>
-              <a:spcBef>
-                <a:spcPts val="0"/>
-              </a:spcBef>
-              <a:spcAft>
-                <a:spcPts val="0"/>
+              <a:spcAft>
+                <a:spcPts val="1200"/>
               </a:spcAft>
               <a:buClr>
                 <a:schemeClr val="dk1"/>
@@ -19152,7 +19584,7 @@
               <a:buChar char="➢"/>
             </a:pPr>
             <a:r>
-              <a:rPr lang="en" sz="1500" b="1">
+              <a:rPr lang="en" sz="1500" b="1" dirty="0">
                 <a:solidFill>
                   <a:schemeClr val="dk1"/>
                 </a:solidFill>
@@ -19160,14 +19592,14 @@
               <a:t>BPE builds tokens by merging frequent pairs.</a:t>
             </a:r>
             <a:r>
-              <a:rPr lang="en" sz="1500">
+              <a:rPr lang="en" sz="1500" dirty="0">
                 <a:solidFill>
                   <a:schemeClr val="dk1"/>
                 </a:solidFill>
               </a:rPr>
               <a:t> Its training data shapes which patterns get compact representations.</a:t>
             </a:r>
-            <a:endParaRPr sz="1500">
+            <a:endParaRPr sz="1500" dirty="0">
               <a:solidFill>
                 <a:schemeClr val="dk1"/>
               </a:solidFill>
@@ -19175,14 +19607,8 @@
           </a:p>
           <a:p>
             <a:pPr marL="457200" lvl="0" indent="-323850" algn="l" rtl="0">
-              <a:lnSpc>
-                <a:spcPct val="150000"/>
-              </a:lnSpc>
-              <a:spcBef>
-                <a:spcPts val="0"/>
-              </a:spcBef>
-              <a:spcAft>
-                <a:spcPts val="0"/>
+              <a:spcAft>
+                <a:spcPts val="1200"/>
               </a:spcAft>
               <a:buClr>
                 <a:schemeClr val="dk1"/>
@@ -19191,7 +19617,7 @@
               <a:buChar char="➢"/>
             </a:pPr>
             <a:r>
-              <a:rPr lang="en" sz="1500" b="1">
+              <a:rPr lang="en" sz="1500" b="1" dirty="0">
                 <a:solidFill>
                   <a:schemeClr val="dk1"/>
                 </a:solidFill>
@@ -19199,29 +19625,23 @@
               <a:t>Fewer tokens mean more room</a:t>
             </a:r>
             <a:r>
-              <a:rPr lang="en" sz="1500">
+              <a:rPr lang="en" sz="1500" dirty="0">
                 <a:solidFill>
                   <a:schemeClr val="dk1"/>
                 </a:solidFill>
               </a:rPr>
               <a:t> in the context window. Different languages and formats use that space differently.</a:t>
             </a:r>
-            <a:endParaRPr sz="1500">
+            <a:endParaRPr sz="1500" dirty="0">
               <a:solidFill>
                 <a:schemeClr val="dk1"/>
               </a:solidFill>
             </a:endParaRPr>
           </a:p>
           <a:p>
-            <a:pPr marL="457200" lvl="0" indent="-323850" algn="l" rtl="0">
-              <a:lnSpc>
-                <a:spcPct val="150000"/>
-              </a:lnSpc>
-              <a:spcBef>
-                <a:spcPts val="0"/>
-              </a:spcBef>
-              <a:spcAft>
-                <a:spcPts val="0"/>
+            <a:pPr marL="457200" lvl="0" indent="-323850">
+              <a:spcAft>
+                <a:spcPts val="1200"/>
               </a:spcAft>
               <a:buClr>
                 <a:schemeClr val="dk1"/>
@@ -19230,37 +19650,26 @@
               <a:buChar char="➢"/>
             </a:pPr>
             <a:r>
-              <a:rPr lang="en" sz="1500" b="1">
-                <a:solidFill>
-                  <a:schemeClr val="dk1"/>
-                </a:solidFill>
-              </a:rPr>
-              <a:t>Token boundaries can be surprising.</a:t>
-            </a:r>
-            <a:r>
-              <a:rPr lang="en" sz="1500">
-                <a:solidFill>
-                  <a:schemeClr val="dk1"/>
-                </a:solidFill>
-              </a:rPr>
-              <a:t> Spaces affect the split, numbers break into chunks, and one character can span multiple tokens when its UTF-8 bytes fall into different tokens. </a:t>
-            </a:r>
-            <a:endParaRPr sz="1500">
-              <a:solidFill>
-                <a:schemeClr val="dk1"/>
-              </a:solidFill>
-            </a:endParaRPr>
-          </a:p>
-          <a:p>
-            <a:pPr marL="457200" lvl="0" indent="-323850" algn="l" rtl="0">
-              <a:lnSpc>
-                <a:spcPct val="150000"/>
-              </a:lnSpc>
-              <a:spcBef>
-                <a:spcPts val="0"/>
-              </a:spcBef>
-              <a:spcAft>
-                <a:spcPts val="0"/>
+              <a:rPr lang="en-US" sz="1500" b="1" dirty="0">
+                <a:solidFill>
+                  <a:schemeClr val="dk1"/>
+                </a:solidFill>
+              </a:rPr>
+              <a:t>The tokenizer can split words in unexpected places. </a:t>
+            </a:r>
+            <a:r>
+              <a:rPr lang="en-US" sz="1500" dirty="0">
+                <a:solidFill>
+                  <a:schemeClr val="dk1"/>
+                </a:solidFill>
+              </a:rPr>
+              <a:t>Splits don’t always follow syllables or familiar word parts. A token can also include the space before a word, so “hello” and “  hello” may use different tokens depending on the tokenizer.</a:t>
+            </a:r>
+          </a:p>
+          <a:p>
+            <a:pPr marL="457200" lvl="0" indent="-323850">
+              <a:spcAft>
+                <a:spcPts val="1200"/>
               </a:spcAft>
               <a:buClr>
                 <a:schemeClr val="dk1"/>
@@ -19269,22 +19678,22 @@
               <a:buChar char="➢"/>
             </a:pPr>
             <a:r>
-              <a:rPr lang="en" sz="1500" b="1">
-                <a:solidFill>
-                  <a:schemeClr val="dk1"/>
-                </a:solidFill>
-              </a:rPr>
-              <a:t>Special tokens provide structure.</a:t>
-            </a:r>
-            <a:r>
-              <a:rPr lang="en" sz="1500">
-                <a:solidFill>
-                  <a:schemeClr val="dk1"/>
-                </a:solidFill>
-              </a:rPr>
-              <a:t> The model learns the format during training, while external software executes tool calls.</a:t>
-            </a:r>
-            <a:endParaRPr sz="1500">
+              <a:rPr lang="en" sz="1500" b="1" dirty="0">
+                <a:solidFill>
+                  <a:schemeClr val="dk1"/>
+                </a:solidFill>
+              </a:rPr>
+              <a:t>Special tokens provide structure. </a:t>
+            </a:r>
+            <a:r>
+              <a:rPr lang="en" sz="1500" dirty="0">
+                <a:solidFill>
+                  <a:schemeClr val="dk1"/>
+                </a:solidFill>
+              </a:rPr>
+              <a:t>The model learns the format during training, while external software executes tool calls.</a:t>
+            </a:r>
+            <a:endParaRPr sz="1500" dirty="0">
               <a:solidFill>
                 <a:schemeClr val="dk1"/>
               </a:solidFill>
@@ -20677,6 +21086,54 @@
           </a:p>
         </p:txBody>
       </p:sp>
+      <p:sp>
+        <p:nvSpPr>
+          <p:cNvPr id="2" name="Google Shape;304;p38">
+            <a:extLst>
+              <a:ext uri="{FF2B5EF4-FFF2-40B4-BE49-F238E27FC236}">
+                <a16:creationId xmlns:a16="http://schemas.microsoft.com/office/drawing/2014/main" id="{C9BC384C-383A-1391-4773-90402F2ED9DB}"/>
+              </a:ext>
+            </a:extLst>
+          </p:cNvPr>
+          <p:cNvSpPr txBox="1">
+            <a:spLocks noGrp="1"/>
+          </p:cNvSpPr>
+          <p:nvPr>
+            <p:ph type="sldNum" idx="12"/>
+          </p:nvPr>
+        </p:nvSpPr>
+        <p:spPr>
+          <a:xfrm>
+            <a:off x="8472458" y="4663217"/>
+            <a:ext cx="548700" cy="393600"/>
+          </a:xfrm>
+          <a:prstGeom prst="rect">
+            <a:avLst/>
+          </a:prstGeom>
+        </p:spPr>
+        <p:txBody>
+          <a:bodyPr spcFirstLastPara="1" wrap="square" lIns="91425" tIns="91425" rIns="91425" bIns="91425" anchor="ctr" anchorCtr="0">
+            <a:normAutofit/>
+          </a:bodyPr>
+          <a:lstStyle/>
+          <a:p>
+            <a:pPr marL="0" lvl="0" indent="0" algn="r" rtl="0">
+              <a:spcBef>
+                <a:spcPts val="0"/>
+              </a:spcBef>
+              <a:spcAft>
+                <a:spcPts val="0"/>
+              </a:spcAft>
+              <a:buNone/>
+            </a:pPr>
+            <a:fld id="{00000000-1234-1234-1234-123412341234}" type="slidenum">
+              <a:rPr lang="en"/>
+              <a:t>27</a:t>
+            </a:fld>
+            <a:endParaRPr dirty="0"/>
+          </a:p>
+        </p:txBody>
+      </p:sp>
     </p:spTree>
   </p:cSld>
   <p:clrMapOvr>
@@ -21706,7 +22163,7 @@
         </p:nvSpPr>
         <p:spPr>
           <a:xfrm>
-            <a:off x="1751414" y="4549550"/>
+            <a:off x="2321250" y="4183808"/>
             <a:ext cx="4501500" cy="400200"/>
           </a:xfrm>
           <a:prstGeom prst="rect">
@@ -21733,7 +22190,7 @@
               <a:buNone/>
             </a:pPr>
             <a:r>
-              <a:rPr lang="en" u="sng">
+              <a:rPr lang="en" u="sng" dirty="0">
                 <a:solidFill>
                   <a:schemeClr val="hlink"/>
                 </a:solidFill>
@@ -21741,7 +22198,7 @@
               </a:rPr>
               <a:t>https://huggingface.co/learn/llm-course/en/chapter6/5</a:t>
             </a:r>
-            <a:endParaRPr/>
+            <a:endParaRPr dirty="0"/>
           </a:p>
         </p:txBody>
       </p:sp>
@@ -21791,11 +22248,17 @@
         <p:nvGraphicFramePr>
           <p:cNvPr id="93" name="Google Shape;93;p17"/>
           <p:cNvGraphicFramePr/>
-          <p:nvPr/>
+          <p:nvPr>
+            <p:extLst>
+              <p:ext uri="{D42A27DB-BD31-4B8C-83A1-F6EECF244321}">
+                <p14:modId xmlns:p14="http://schemas.microsoft.com/office/powerpoint/2010/main" val="3270992400"/>
+              </p:ext>
+            </p:extLst>
+          </p:nvPr>
         </p:nvGraphicFramePr>
         <p:xfrm>
-          <a:off x="290313" y="2028413"/>
-          <a:ext cx="6631775" cy="2350399"/>
+          <a:off x="232306" y="1353398"/>
+          <a:ext cx="7664856" cy="2726503"/>
         </p:xfrm>
         <a:graphic>
           <a:graphicData uri="http://schemas.openxmlformats.org/drawingml/2006/table">
@@ -21805,31 +22268,38 @@
                 <a:tableStyleId>{D596C1CA-8488-4DA9-8845-881FBA825FD5}</a:tableStyleId>
               </a:tblPr>
               <a:tblGrid>
-                <a:gridCol w="2178100">
+                <a:gridCol w="2412678">
                   <a:extLst>
                     <a:ext uri="{9D8B030D-6E8A-4147-A177-3AD203B41FA5}">
                       <a16:colId xmlns:a16="http://schemas.microsoft.com/office/drawing/2014/main" val="20000"/>
                     </a:ext>
                   </a:extLst>
                 </a:gridCol>
-                <a:gridCol w="1694975">
+                <a:gridCol w="1510565">
                   <a:extLst>
                     <a:ext uri="{9D8B030D-6E8A-4147-A177-3AD203B41FA5}">
                       <a16:colId xmlns:a16="http://schemas.microsoft.com/office/drawing/2014/main" val="20001"/>
                     </a:ext>
                   </a:extLst>
                 </a:gridCol>
-                <a:gridCol w="1477925">
+                <a:gridCol w="1532699">
                   <a:extLst>
                     <a:ext uri="{9D8B030D-6E8A-4147-A177-3AD203B41FA5}">
                       <a16:colId xmlns:a16="http://schemas.microsoft.com/office/drawing/2014/main" val="20002"/>
                     </a:ext>
                   </a:extLst>
                 </a:gridCol>
-                <a:gridCol w="1280775">
+                <a:gridCol w="743959">
                   <a:extLst>
                     <a:ext uri="{9D8B030D-6E8A-4147-A177-3AD203B41FA5}">
                       <a16:colId xmlns:a16="http://schemas.microsoft.com/office/drawing/2014/main" val="20003"/>
+                    </a:ext>
+                  </a:extLst>
+                </a:gridCol>
+                <a:gridCol w="1464955">
+                  <a:extLst>
+                    <a:ext uri="{9D8B030D-6E8A-4147-A177-3AD203B41FA5}">
+                      <a16:colId xmlns:a16="http://schemas.microsoft.com/office/drawing/2014/main" val="4144989667"/>
                     </a:ext>
                   </a:extLst>
                 </a:gridCol>
@@ -21853,10 +22323,10 @@
                         <a:buNone/>
                       </a:pPr>
                       <a:r>
-                        <a:rPr lang="en" sz="1100" b="1"/>
+                        <a:rPr lang="en" sz="1100" b="1" dirty="0"/>
                         <a:t>Step</a:t>
                       </a:r>
-                      <a:endParaRPr sz="1100" b="1"/>
+                      <a:endParaRPr sz="1100" b="1" dirty="0"/>
                     </a:p>
                   </a:txBody>
                   <a:tcPr marL="91425" marR="91425" marT="91425" marB="91425">
@@ -22042,10 +22512,73 @@
                         <a:buNone/>
                       </a:pPr>
                       <a:r>
-                        <a:rPr lang="en" sz="1100" b="1"/>
+                        <a:rPr lang="en" sz="1100" b="1" dirty="0"/>
                         <a:t>New token added</a:t>
                       </a:r>
-                      <a:endParaRPr sz="1100" b="1"/>
+                      <a:endParaRPr sz="1100" b="1" dirty="0"/>
+                    </a:p>
+                  </a:txBody>
+                  <a:tcPr marL="91425" marR="91425" marT="91425" marB="91425">
+                    <a:lnL w="9525" cap="flat" cmpd="sng">
+                      <a:solidFill>
+                        <a:schemeClr val="dk1"/>
+                      </a:solidFill>
+                      <a:prstDash val="solid"/>
+                      <a:round/>
+                      <a:headEnd type="none" w="sm" len="sm"/>
+                      <a:tailEnd type="none" w="sm" len="sm"/>
+                    </a:lnL>
+                    <a:lnR w="9525" cap="flat" cmpd="sng" algn="ctr">
+                      <a:solidFill>
+                        <a:schemeClr val="dk1"/>
+                      </a:solidFill>
+                      <a:prstDash val="solid"/>
+                      <a:round/>
+                      <a:headEnd type="none" w="sm" len="sm"/>
+                      <a:tailEnd type="none" w="sm" len="sm"/>
+                    </a:lnR>
+                    <a:lnT w="9525" cap="flat" cmpd="sng">
+                      <a:solidFill>
+                        <a:schemeClr val="dk1"/>
+                      </a:solidFill>
+                      <a:prstDash val="solid"/>
+                      <a:round/>
+                      <a:headEnd type="none" w="sm" len="sm"/>
+                      <a:tailEnd type="none" w="sm" len="sm"/>
+                    </a:lnT>
+                    <a:lnB w="9525" cap="flat" cmpd="sng">
+                      <a:solidFill>
+                        <a:schemeClr val="dk1"/>
+                      </a:solidFill>
+                      <a:prstDash val="solid"/>
+                      <a:round/>
+                      <a:headEnd type="none" w="sm" len="sm"/>
+                      <a:tailEnd type="none" w="sm" len="sm"/>
+                    </a:lnB>
+                  </a:tcPr>
+                </a:tc>
+                <a:tc>
+                  <a:txBody>
+                    <a:bodyPr/>
+                    <a:lstStyle/>
+                    <a:p>
+                      <a:pPr marL="0" lvl="0" indent="0" algn="ctr" rtl="0">
+                        <a:lnSpc>
+                          <a:spcPct val="115000"/>
+                        </a:lnSpc>
+                        <a:spcBef>
+                          <a:spcPts val="0"/>
+                        </a:spcBef>
+                        <a:spcAft>
+                          <a:spcPts val="0"/>
+                        </a:spcAft>
+                        <a:buNone/>
+                      </a:pPr>
+                      <a:r>
+                        <a:rPr lang="de-DE" sz="1100" b="1" dirty="0"/>
+                        <a:t>ID</a:t>
+                      </a:r>
+                      <a:endParaRPr sz="1100" b="1" dirty="0"/>
                     </a:p>
                   </a:txBody>
                   <a:tcPr marL="91425" marR="91425" marT="91425" marB="91425">
@@ -22076,7 +22609,7 @@
                       <a:headEnd type="none" w="sm" len="sm"/>
                       <a:tailEnd type="none" w="sm" len="sm"/>
                     </a:lnT>
-                    <a:lnB w="9525" cap="flat" cmpd="sng">
+                    <a:lnB w="9525" cap="flat" cmpd="sng" algn="ctr">
                       <a:solidFill>
                         <a:schemeClr val="dk1"/>
                       </a:solidFill>
@@ -22109,10 +22642,10 @@
                         <a:buNone/>
                       </a:pPr>
                       <a:r>
-                        <a:rPr lang="en"/>
+                        <a:rPr lang="en" dirty="0"/>
                         <a:t>Start</a:t>
                       </a:r>
-                      <a:endParaRPr/>
+                      <a:endParaRPr dirty="0"/>
                     </a:p>
                   </a:txBody>
                   <a:tcPr marL="91425" marR="91425" marT="91425" marB="91425">
@@ -22321,7 +22854,7 @@
                         <a:buNone/>
                       </a:pPr>
                       <a:r>
-                        <a:rPr lang="en" sz="1100">
+                        <a:rPr lang="en" sz="1100" dirty="0">
                           <a:solidFill>
                             <a:schemeClr val="accent1"/>
                           </a:solidFill>
@@ -22332,9 +22865,166 @@
                         </a:rPr>
                         <a:t>None</a:t>
                       </a:r>
-                      <a:endParaRPr sz="1100">
+                      <a:endParaRPr sz="1100" dirty="0">
                         <a:solidFill>
                           <a:schemeClr val="accent1"/>
+                        </a:solidFill>
+                        <a:latin typeface="Roboto Mono"/>
+                        <a:ea typeface="Roboto Mono"/>
+                        <a:cs typeface="Roboto Mono"/>
+                        <a:sym typeface="Roboto Mono"/>
+                      </a:endParaRPr>
+                    </a:p>
+                  </a:txBody>
+                  <a:tcPr marL="91425" marR="91425" marT="91425" marB="91425">
+                    <a:lnL w="9525" cap="flat" cmpd="sng">
+                      <a:solidFill>
+                        <a:schemeClr val="dk1"/>
+                      </a:solidFill>
+                      <a:prstDash val="solid"/>
+                      <a:round/>
+                      <a:headEnd type="none" w="sm" len="sm"/>
+                      <a:tailEnd type="none" w="sm" len="sm"/>
+                    </a:lnL>
+                    <a:lnR w="9525" cap="flat" cmpd="sng" algn="ctr">
+                      <a:solidFill>
+                        <a:schemeClr val="dk1"/>
+                      </a:solidFill>
+                      <a:prstDash val="solid"/>
+                      <a:round/>
+                      <a:headEnd type="none" w="sm" len="sm"/>
+                      <a:tailEnd type="none" w="sm" len="sm"/>
+                    </a:lnR>
+                    <a:lnT w="9525" cap="flat" cmpd="sng">
+                      <a:solidFill>
+                        <a:schemeClr val="dk1"/>
+                      </a:solidFill>
+                      <a:prstDash val="solid"/>
+                      <a:round/>
+                      <a:headEnd type="none" w="sm" len="sm"/>
+                      <a:tailEnd type="none" w="sm" len="sm"/>
+                    </a:lnT>
+                    <a:lnB w="9525" cap="flat" cmpd="sng">
+                      <a:solidFill>
+                        <a:schemeClr val="dk1"/>
+                      </a:solidFill>
+                      <a:prstDash val="solid"/>
+                      <a:round/>
+                      <a:headEnd type="none" w="sm" len="sm"/>
+                      <a:tailEnd type="none" w="sm" len="sm"/>
+                    </a:lnB>
+                  </a:tcPr>
+                </a:tc>
+                <a:tc>
+                  <a:txBody>
+                    <a:bodyPr/>
+                    <a:lstStyle/>
+                    <a:p>
+                      <a:pPr marL="0" lvl="0" indent="0" algn="ctr" rtl="0">
+                        <a:spcBef>
+                          <a:spcPts val="0"/>
+                        </a:spcBef>
+                        <a:spcAft>
+                          <a:spcPts val="0"/>
+                        </a:spcAft>
+                        <a:buNone/>
+                      </a:pPr>
+                      <a:r>
+                        <a:rPr lang="de-DE" sz="1100" dirty="0">
+                          <a:solidFill>
+                            <a:schemeClr val="accent1"/>
+                          </a:solidFill>
+                          <a:latin typeface="Roboto Mono"/>
+                          <a:ea typeface="Roboto Mono"/>
+                          <a:cs typeface="Roboto Mono"/>
+                          <a:sym typeface="Roboto Mono"/>
+                        </a:rPr>
+                        <a:t>[h] - 1,</a:t>
+                      </a:r>
+                    </a:p>
+                    <a:p>
+                      <a:pPr marL="0" lvl="0" indent="0" algn="ctr" rtl="0">
+                        <a:spcBef>
+                          <a:spcPts val="0"/>
+                        </a:spcBef>
+                        <a:spcAft>
+                          <a:spcPts val="0"/>
+                        </a:spcAft>
+                        <a:buNone/>
+                      </a:pPr>
+                      <a:r>
+                        <a:rPr lang="de-DE" sz="1100" dirty="0">
+                          <a:solidFill>
+                            <a:schemeClr val="accent1"/>
+                          </a:solidFill>
+                          <a:latin typeface="Roboto Mono"/>
+                          <a:ea typeface="Roboto Mono"/>
+                          <a:cs typeface="Roboto Mono"/>
+                          <a:sym typeface="Roboto Mono"/>
+                        </a:rPr>
+                        <a:t>[u] - 2,</a:t>
+                      </a:r>
+                    </a:p>
+                    <a:p>
+                      <a:pPr marL="0" lvl="0" indent="0" algn="ctr" rtl="0">
+                        <a:spcBef>
+                          <a:spcPts val="0"/>
+                        </a:spcBef>
+                        <a:spcAft>
+                          <a:spcPts val="0"/>
+                        </a:spcAft>
+                        <a:buNone/>
+                      </a:pPr>
+                      <a:r>
+                        <a:rPr lang="de-DE" sz="1100" dirty="0">
+                          <a:solidFill>
+                            <a:schemeClr val="accent1"/>
+                          </a:solidFill>
+                          <a:latin typeface="Roboto Mono"/>
+                          <a:ea typeface="Roboto Mono"/>
+                          <a:cs typeface="Roboto Mono"/>
+                          <a:sym typeface="Roboto Mono"/>
+                        </a:rPr>
+                        <a:t>[g] - 3, </a:t>
+                      </a:r>
+                    </a:p>
+                    <a:p>
+                      <a:pPr marL="0" lvl="0" indent="0" algn="ctr" rtl="0">
+                        <a:spcBef>
+                          <a:spcPts val="0"/>
+                        </a:spcBef>
+                        <a:spcAft>
+                          <a:spcPts val="0"/>
+                        </a:spcAft>
+                        <a:buNone/>
+                      </a:pPr>
+                      <a:r>
+                        <a:rPr lang="de-DE" sz="1100" dirty="0">
+                          <a:solidFill>
+                            <a:schemeClr val="accent1"/>
+                          </a:solidFill>
+                          <a:latin typeface="Roboto Mono"/>
+                          <a:ea typeface="Roboto Mono"/>
+                          <a:cs typeface="Roboto Mono"/>
+                          <a:sym typeface="Roboto Mono"/>
+                        </a:rPr>
+                        <a:t>[p] - 4</a:t>
+                      </a:r>
+                      <a:r>
+                        <a:rPr lang="de-DE" sz="1100" dirty="0">
+                          <a:solidFill>
+                            <a:schemeClr val="bg1"/>
+                          </a:solidFill>
+                          <a:latin typeface="Roboto Mono"/>
+                          <a:ea typeface="Roboto Mono"/>
+                          <a:cs typeface="Roboto Mono"/>
+                          <a:sym typeface="Roboto Mono"/>
+                        </a:rPr>
+                        <a:t>,</a:t>
+                      </a:r>
+                      <a:endParaRPr sz="1100" dirty="0">
+                        <a:solidFill>
+                          <a:schemeClr val="bg1"/>
                         </a:solidFill>
                         <a:latin typeface="Roboto Mono"/>
                         <a:ea typeface="Roboto Mono"/>
@@ -22362,7 +23052,7 @@
                       <a:headEnd type="none" w="sm" len="sm"/>
                       <a:tailEnd type="none" w="sm" len="sm"/>
                     </a:lnR>
-                    <a:lnT w="9525" cap="flat" cmpd="sng">
+                    <a:lnT w="9525" cap="flat" cmpd="sng" algn="ctr">
                       <a:solidFill>
                         <a:schemeClr val="dk1"/>
                       </a:solidFill>
@@ -22371,7 +23061,7 @@
                       <a:headEnd type="none" w="sm" len="sm"/>
                       <a:tailEnd type="none" w="sm" len="sm"/>
                     </a:lnT>
-                    <a:lnB w="9525" cap="flat" cmpd="sng">
+                    <a:lnB w="9525" cap="flat" cmpd="sng" algn="ctr">
                       <a:solidFill>
                         <a:schemeClr val="dk1"/>
                       </a:solidFill>
@@ -22404,11 +23094,11 @@
                         <a:buNone/>
                       </a:pPr>
                       <a:r>
-                        <a:rPr lang="en" sz="1100"/>
+                        <a:rPr lang="en" sz="1100" dirty="0"/>
                         <a:t>Merge </a:t>
                       </a:r>
                       <a:r>
-                        <a:rPr lang="en" sz="1100">
+                        <a:rPr lang="en" sz="1100" dirty="0">
                           <a:solidFill>
                             <a:schemeClr val="accent1"/>
                           </a:solidFill>
@@ -22420,11 +23110,11 @@
                         <a:t>u</a:t>
                       </a:r>
                       <a:r>
-                        <a:rPr lang="en" sz="1100"/>
+                        <a:rPr lang="en" sz="1100" dirty="0"/>
                         <a:t> + </a:t>
                       </a:r>
                       <a:r>
-                        <a:rPr lang="en" sz="1100">
+                        <a:rPr lang="en" sz="1100" dirty="0">
                           <a:solidFill>
                             <a:schemeClr val="accent1"/>
                           </a:solidFill>
@@ -22436,10 +23126,10 @@
                         <a:t>g</a:t>
                       </a:r>
                       <a:r>
-                        <a:rPr lang="en" sz="1100"/>
+                        <a:rPr lang="en" sz="1100" dirty="0"/>
                         <a:t> (5 occurrences)</a:t>
                       </a:r>
-                      <a:endParaRPr sz="1100"/>
+                      <a:endParaRPr sz="1100" dirty="0"/>
                     </a:p>
                   </a:txBody>
                   <a:tcPr marL="91425" marR="91425" marT="91425" marB="91425">
@@ -22648,7 +23338,7 @@
                         <a:buNone/>
                       </a:pPr>
                       <a:r>
-                        <a:rPr lang="en" sz="1100">
+                        <a:rPr lang="en" sz="1100" dirty="0">
                           <a:solidFill>
                             <a:schemeClr val="accent1"/>
                           </a:solidFill>
@@ -22659,7 +23349,83 @@
                         </a:rPr>
                         <a:t>[ug]</a:t>
                       </a:r>
-                      <a:endParaRPr sz="1100">
+                      <a:endParaRPr sz="1100" dirty="0">
+                        <a:solidFill>
+                          <a:schemeClr val="accent1"/>
+                        </a:solidFill>
+                        <a:latin typeface="Roboto Mono"/>
+                        <a:ea typeface="Roboto Mono"/>
+                        <a:cs typeface="Roboto Mono"/>
+                        <a:sym typeface="Roboto Mono"/>
+                      </a:endParaRPr>
+                    </a:p>
+                  </a:txBody>
+                  <a:tcPr marL="91425" marR="91425" marT="91425" marB="91425">
+                    <a:lnL w="9525" cap="flat" cmpd="sng">
+                      <a:solidFill>
+                        <a:schemeClr val="dk1"/>
+                      </a:solidFill>
+                      <a:prstDash val="solid"/>
+                      <a:round/>
+                      <a:headEnd type="none" w="sm" len="sm"/>
+                      <a:tailEnd type="none" w="sm" len="sm"/>
+                    </a:lnL>
+                    <a:lnR w="9525" cap="flat" cmpd="sng" algn="ctr">
+                      <a:solidFill>
+                        <a:schemeClr val="dk1"/>
+                      </a:solidFill>
+                      <a:prstDash val="solid"/>
+                      <a:round/>
+                      <a:headEnd type="none" w="sm" len="sm"/>
+                      <a:tailEnd type="none" w="sm" len="sm"/>
+                    </a:lnR>
+                    <a:lnT w="9525" cap="flat" cmpd="sng">
+                      <a:solidFill>
+                        <a:schemeClr val="dk1"/>
+                      </a:solidFill>
+                      <a:prstDash val="solid"/>
+                      <a:round/>
+                      <a:headEnd type="none" w="sm" len="sm"/>
+                      <a:tailEnd type="none" w="sm" len="sm"/>
+                    </a:lnT>
+                    <a:lnB w="9525" cap="flat" cmpd="sng">
+                      <a:solidFill>
+                        <a:schemeClr val="dk1"/>
+                      </a:solidFill>
+                      <a:prstDash val="solid"/>
+                      <a:round/>
+                      <a:headEnd type="none" w="sm" len="sm"/>
+                      <a:tailEnd type="none" w="sm" len="sm"/>
+                    </a:lnB>
+                  </a:tcPr>
+                </a:tc>
+                <a:tc>
+                  <a:txBody>
+                    <a:bodyPr/>
+                    <a:lstStyle/>
+                    <a:p>
+                      <a:pPr marL="0" lvl="0" indent="0" algn="ctr" rtl="0">
+                        <a:spcBef>
+                          <a:spcPts val="0"/>
+                        </a:spcBef>
+                        <a:spcAft>
+                          <a:spcPts val="0"/>
+                        </a:spcAft>
+                        <a:buNone/>
+                      </a:pPr>
+                      <a:r>
+                        <a:rPr lang="de-DE" sz="1100" dirty="0">
+                          <a:solidFill>
+                            <a:schemeClr val="accent1"/>
+                          </a:solidFill>
+                          <a:latin typeface="Roboto Mono"/>
+                          <a:ea typeface="Roboto Mono"/>
+                          <a:cs typeface="Roboto Mono"/>
+                          <a:sym typeface="Roboto Mono"/>
+                        </a:rPr>
+                        <a:t>5</a:t>
+                      </a:r>
+                      <a:endParaRPr sz="1100" dirty="0">
                         <a:solidFill>
                           <a:schemeClr val="accent1"/>
                         </a:solidFill>
@@ -22689,7 +23455,7 @@
                       <a:headEnd type="none" w="sm" len="sm"/>
                       <a:tailEnd type="none" w="sm" len="sm"/>
                     </a:lnR>
-                    <a:lnT w="9525" cap="flat" cmpd="sng">
+                    <a:lnT w="9525" cap="flat" cmpd="sng" algn="ctr">
                       <a:solidFill>
                         <a:schemeClr val="dk1"/>
                       </a:solidFill>
@@ -22698,7 +23464,7 @@
                       <a:headEnd type="none" w="sm" len="sm"/>
                       <a:tailEnd type="none" w="sm" len="sm"/>
                     </a:lnT>
-                    <a:lnB w="9525" cap="flat" cmpd="sng">
+                    <a:lnB w="9525" cap="flat" cmpd="sng" algn="ctr">
                       <a:solidFill>
                         <a:schemeClr val="dk1"/>
                       </a:solidFill>
@@ -22715,7 +23481,7 @@
                   </a:ext>
                 </a:extLst>
               </a:tr>
-              <a:tr h="558475">
+              <a:tr h="361978">
                 <a:tc>
                   <a:txBody>
                     <a:bodyPr/>
@@ -22975,7 +23741,7 @@
                         <a:buNone/>
                       </a:pPr>
                       <a:r>
-                        <a:rPr lang="en" sz="1100">
+                        <a:rPr lang="en" sz="1100" dirty="0">
                           <a:solidFill>
                             <a:schemeClr val="accent1"/>
                           </a:solidFill>
@@ -22986,7 +23752,83 @@
                         </a:rPr>
                         <a:t>[hug]</a:t>
                       </a:r>
-                      <a:endParaRPr sz="1100">
+                      <a:endParaRPr sz="1100" dirty="0">
+                        <a:solidFill>
+                          <a:schemeClr val="accent1"/>
+                        </a:solidFill>
+                        <a:latin typeface="Roboto Mono"/>
+                        <a:ea typeface="Roboto Mono"/>
+                        <a:cs typeface="Roboto Mono"/>
+                        <a:sym typeface="Roboto Mono"/>
+                      </a:endParaRPr>
+                    </a:p>
+                  </a:txBody>
+                  <a:tcPr marL="91425" marR="91425" marT="91425" marB="91425">
+                    <a:lnL w="9525" cap="flat" cmpd="sng">
+                      <a:solidFill>
+                        <a:schemeClr val="dk1"/>
+                      </a:solidFill>
+                      <a:prstDash val="solid"/>
+                      <a:round/>
+                      <a:headEnd type="none" w="sm" len="sm"/>
+                      <a:tailEnd type="none" w="sm" len="sm"/>
+                    </a:lnL>
+                    <a:lnR w="9525" cap="flat" cmpd="sng" algn="ctr">
+                      <a:solidFill>
+                        <a:schemeClr val="dk1"/>
+                      </a:solidFill>
+                      <a:prstDash val="solid"/>
+                      <a:round/>
+                      <a:headEnd type="none" w="sm" len="sm"/>
+                      <a:tailEnd type="none" w="sm" len="sm"/>
+                    </a:lnR>
+                    <a:lnT w="9525" cap="flat" cmpd="sng">
+                      <a:solidFill>
+                        <a:schemeClr val="dk1"/>
+                      </a:solidFill>
+                      <a:prstDash val="solid"/>
+                      <a:round/>
+                      <a:headEnd type="none" w="sm" len="sm"/>
+                      <a:tailEnd type="none" w="sm" len="sm"/>
+                    </a:lnT>
+                    <a:lnB w="9525" cap="flat" cmpd="sng">
+                      <a:solidFill>
+                        <a:schemeClr val="dk1"/>
+                      </a:solidFill>
+                      <a:prstDash val="solid"/>
+                      <a:round/>
+                      <a:headEnd type="none" w="sm" len="sm"/>
+                      <a:tailEnd type="none" w="sm" len="sm"/>
+                    </a:lnB>
+                  </a:tcPr>
+                </a:tc>
+                <a:tc>
+                  <a:txBody>
+                    <a:bodyPr/>
+                    <a:lstStyle/>
+                    <a:p>
+                      <a:pPr marL="0" lvl="0" indent="0" algn="ctr" rtl="0">
+                        <a:spcBef>
+                          <a:spcPts val="0"/>
+                        </a:spcBef>
+                        <a:spcAft>
+                          <a:spcPts val="0"/>
+                        </a:spcAft>
+                        <a:buNone/>
+                      </a:pPr>
+                      <a:r>
+                        <a:rPr lang="de-DE" sz="1100" dirty="0">
+                          <a:solidFill>
+                            <a:schemeClr val="accent1"/>
+                          </a:solidFill>
+                          <a:latin typeface="Roboto Mono"/>
+                          <a:ea typeface="Roboto Mono"/>
+                          <a:cs typeface="Roboto Mono"/>
+                          <a:sym typeface="Roboto Mono"/>
+                        </a:rPr>
+                        <a:t>6</a:t>
+                      </a:r>
+                      <a:endParaRPr sz="1100" dirty="0">
                         <a:solidFill>
                           <a:schemeClr val="accent1"/>
                         </a:solidFill>
@@ -23016,7 +23858,7 @@
                       <a:headEnd type="none" w="sm" len="sm"/>
                       <a:tailEnd type="none" w="sm" len="sm"/>
                     </a:lnR>
-                    <a:lnT w="9525" cap="flat" cmpd="sng">
+                    <a:lnT w="9525" cap="flat" cmpd="sng" algn="ctr">
                       <a:solidFill>
                         <a:schemeClr val="dk1"/>
                       </a:solidFill>
@@ -23025,7 +23867,7 @@
                       <a:headEnd type="none" w="sm" len="sm"/>
                       <a:tailEnd type="none" w="sm" len="sm"/>
                     </a:lnT>
-                    <a:lnB w="9525" cap="flat" cmpd="sng">
+                    <a:lnB w="9525" cap="flat" cmpd="sng" algn="ctr">
                       <a:solidFill>
                         <a:schemeClr val="dk1"/>
                       </a:solidFill>
@@ -23042,7 +23884,7 @@
                   </a:ext>
                 </a:extLst>
               </a:tr>
-              <a:tr h="427875">
+              <a:tr h="335121">
                 <a:tc>
                   <a:txBody>
                     <a:bodyPr/>
@@ -23302,7 +24144,7 @@
                         <a:buNone/>
                       </a:pPr>
                       <a:r>
-                        <a:rPr lang="en" sz="1100">
+                        <a:rPr lang="en" sz="1100" dirty="0">
                           <a:solidFill>
                             <a:schemeClr val="accent1"/>
                           </a:solidFill>
@@ -23313,7 +24155,83 @@
                         </a:rPr>
                         <a:t>[pug]</a:t>
                       </a:r>
-                      <a:endParaRPr sz="1100">
+                      <a:endParaRPr sz="1100" dirty="0">
+                        <a:solidFill>
+                          <a:schemeClr val="accent1"/>
+                        </a:solidFill>
+                        <a:latin typeface="Roboto Mono"/>
+                        <a:ea typeface="Roboto Mono"/>
+                        <a:cs typeface="Roboto Mono"/>
+                        <a:sym typeface="Roboto Mono"/>
+                      </a:endParaRPr>
+                    </a:p>
+                  </a:txBody>
+                  <a:tcPr marL="91425" marR="91425" marT="91425" marB="91425">
+                    <a:lnL w="9525" cap="flat" cmpd="sng">
+                      <a:solidFill>
+                        <a:schemeClr val="dk1"/>
+                      </a:solidFill>
+                      <a:prstDash val="solid"/>
+                      <a:round/>
+                      <a:headEnd type="none" w="sm" len="sm"/>
+                      <a:tailEnd type="none" w="sm" len="sm"/>
+                    </a:lnL>
+                    <a:lnR w="9525" cap="flat" cmpd="sng" algn="ctr">
+                      <a:solidFill>
+                        <a:schemeClr val="dk1"/>
+                      </a:solidFill>
+                      <a:prstDash val="solid"/>
+                      <a:round/>
+                      <a:headEnd type="none" w="sm" len="sm"/>
+                      <a:tailEnd type="none" w="sm" len="sm"/>
+                    </a:lnR>
+                    <a:lnT w="9525" cap="flat" cmpd="sng">
+                      <a:solidFill>
+                        <a:schemeClr val="dk1"/>
+                      </a:solidFill>
+                      <a:prstDash val="solid"/>
+                      <a:round/>
+                      <a:headEnd type="none" w="sm" len="sm"/>
+                      <a:tailEnd type="none" w="sm" len="sm"/>
+                    </a:lnT>
+                    <a:lnB w="9525" cap="flat" cmpd="sng">
+                      <a:solidFill>
+                        <a:schemeClr val="dk1"/>
+                      </a:solidFill>
+                      <a:prstDash val="solid"/>
+                      <a:round/>
+                      <a:headEnd type="none" w="sm" len="sm"/>
+                      <a:tailEnd type="none" w="sm" len="sm"/>
+                    </a:lnB>
+                  </a:tcPr>
+                </a:tc>
+                <a:tc>
+                  <a:txBody>
+                    <a:bodyPr/>
+                    <a:lstStyle/>
+                    <a:p>
+                      <a:pPr marL="0" lvl="0" indent="0" algn="ctr" rtl="0">
+                        <a:spcBef>
+                          <a:spcPts val="0"/>
+                        </a:spcBef>
+                        <a:spcAft>
+                          <a:spcPts val="0"/>
+                        </a:spcAft>
+                        <a:buNone/>
+                      </a:pPr>
+                      <a:r>
+                        <a:rPr lang="de-DE" sz="1100" dirty="0">
+                          <a:solidFill>
+                            <a:schemeClr val="accent1"/>
+                          </a:solidFill>
+                          <a:latin typeface="Roboto Mono"/>
+                          <a:ea typeface="Roboto Mono"/>
+                          <a:cs typeface="Roboto Mono"/>
+                          <a:sym typeface="Roboto Mono"/>
+                        </a:rPr>
+                        <a:t>7</a:t>
+                      </a:r>
+                      <a:endParaRPr sz="1100" dirty="0">
                         <a:solidFill>
                           <a:schemeClr val="accent1"/>
                         </a:solidFill>
@@ -23343,7 +24261,7 @@
                       <a:headEnd type="none" w="sm" len="sm"/>
                       <a:tailEnd type="none" w="sm" len="sm"/>
                     </a:lnR>
-                    <a:lnT w="9525" cap="flat" cmpd="sng">
+                    <a:lnT w="9525" cap="flat" cmpd="sng" algn="ctr">
                       <a:solidFill>
                         <a:schemeClr val="dk1"/>
                       </a:solidFill>
@@ -23381,7 +24299,7 @@
         </p:nvSpPr>
         <p:spPr>
           <a:xfrm>
-            <a:off x="176963" y="1042713"/>
+            <a:off x="133876" y="633891"/>
             <a:ext cx="4501500" cy="415500"/>
           </a:xfrm>
           <a:prstGeom prst="rect">
@@ -23411,7 +24329,7 @@
               <a:buNone/>
             </a:pPr>
             <a:r>
-              <a:rPr lang="en" sz="1500" b="1">
+              <a:rPr lang="en" sz="1500" b="1" dirty="0">
                 <a:solidFill>
                   <a:schemeClr val="dk1"/>
                 </a:solidFill>
@@ -23419,7 +24337,7 @@
               <a:t>Example training text:</a:t>
             </a:r>
             <a:r>
-              <a:rPr lang="en" sz="1500">
+              <a:rPr lang="en" sz="1500" dirty="0">
                 <a:solidFill>
                   <a:schemeClr val="dk1"/>
                 </a:solidFill>
@@ -23427,7 +24345,7 @@
               <a:t> </a:t>
             </a:r>
             <a:r>
-              <a:rPr lang="en" sz="1500">
+              <a:rPr lang="en" sz="1500" dirty="0">
                 <a:solidFill>
                   <a:schemeClr val="accent1"/>
                 </a:solidFill>
@@ -23438,7 +24356,7 @@
               </a:rPr>
               <a:t>hug hug hug pug pug</a:t>
             </a:r>
-            <a:endParaRPr sz="1500">
+            <a:endParaRPr sz="1500" dirty="0">
               <a:solidFill>
                 <a:schemeClr val="accent1"/>
               </a:solidFill>
@@ -23458,8 +24376,8 @@
         </p:nvSpPr>
         <p:spPr>
           <a:xfrm>
-            <a:off x="7291223" y="2639475"/>
-            <a:ext cx="1812600" cy="938100"/>
+            <a:off x="8108247" y="2367290"/>
+            <a:ext cx="1035753" cy="1600408"/>
           </a:xfrm>
           <a:prstGeom prst="rect">
             <a:avLst/>
@@ -23475,45 +24393,25 @@
           </a:bodyPr>
           <a:lstStyle/>
           <a:p>
-            <a:pPr marL="0" lvl="0" indent="0" algn="l" rtl="0">
-              <a:lnSpc>
-                <a:spcPct val="115000"/>
-              </a:lnSpc>
+            <a:pPr lvl="0">
               <a:spcBef>
                 <a:spcPts val="1200"/>
               </a:spcBef>
               <a:spcAft>
                 <a:spcPts val="1200"/>
               </a:spcAft>
-              <a:buNone/>
             </a:pPr>
             <a:r>
-              <a:rPr lang="en" sz="1100">
-                <a:solidFill>
-                  <a:schemeClr val="dk1"/>
-                </a:solidFill>
-              </a:rPr>
-              <a:t>Each separate block represents </a:t>
-            </a:r>
-            <a:r>
-              <a:rPr lang="en" sz="1100" b="1">
-                <a:solidFill>
-                  <a:schemeClr val="dk1"/>
-                </a:solidFill>
-              </a:rPr>
-              <a:t>one token</a:t>
-            </a:r>
-            <a:r>
-              <a:rPr lang="en" sz="1100">
-                <a:solidFill>
-                  <a:schemeClr val="dk1"/>
-                </a:solidFill>
-              </a:rPr>
-              <a:t>. We process each word separately.</a:t>
-            </a:r>
-            <a:endParaRPr sz="1100">
+              <a:rPr lang="en-US" sz="800" dirty="0">
+                <a:solidFill>
+                  <a:srgbClr val="FF0000"/>
+                </a:solidFill>
+              </a:rPr>
+              <a:t>Each bracketed group is one token. In this example, we join pieces of the same word, but never across the spaces between words.</a:t>
+            </a:r>
+            <a:endParaRPr sz="800" dirty="0">
               <a:solidFill>
-                <a:schemeClr val="dk1"/>
+                <a:srgbClr val="FF0000"/>
               </a:solidFill>
             </a:endParaRPr>
           </a:p>
@@ -23527,8 +24425,8 @@
         </p:nvSpPr>
         <p:spPr>
           <a:xfrm>
-            <a:off x="7073723" y="2028425"/>
-            <a:ext cx="217500" cy="2167800"/>
+            <a:off x="7951621" y="2110622"/>
+            <a:ext cx="217500" cy="1950972"/>
           </a:xfrm>
           <a:prstGeom prst="downArrow">
             <a:avLst>
@@ -24101,7 +24999,7 @@
               <a:buNone/>
             </a:pPr>
             <a:r>
-              <a:rPr lang="en" sz="1500" b="1" u="sng">
+              <a:rPr lang="en" sz="1500" b="1" u="sng" dirty="0">
                 <a:solidFill>
                   <a:schemeClr val="hlink"/>
                 </a:solidFill>
@@ -24110,14 +25008,14 @@
               <a:t>https://tiktokenizer.vercel.app/</a:t>
             </a:r>
             <a:r>
-              <a:rPr lang="en" sz="1500" b="1">
+              <a:rPr lang="en" sz="1500" b="1" dirty="0">
                 <a:solidFill>
                   <a:schemeClr val="dk1"/>
                 </a:solidFill>
               </a:rPr>
               <a:t> </a:t>
             </a:r>
-            <a:endParaRPr sz="1500" b="1"/>
+            <a:endParaRPr sz="1500" b="1" dirty="0"/>
           </a:p>
         </p:txBody>
       </p:sp>

</xml_diff>